<commit_message>
docs(defensa): guion, arquitectura y diapositivas al día con el código
- Referencias archivo:línea corregidas (18 apuntaban a líneas corridas) y
  filas nuevas en el índice: recomendaciones, controles de Groq, firma de
  la proyección, escala versionada y clave de firma.
- Estado fiscal: año en curso + proyección hasta diciembre (HU-10), con el
  semáforo sobre la proyección; no "12 meses móviles".
- Prophet: 10 ingresos y 3 meses cerrados; media móvil de totales mensuales.
- Huella de alertas: el registro que las originó, no (tipo, monto).
- Escala de monotributo con histórico en la base (migración 0012).
- Aviso de alcance en seis pantallas; recomendaciones en su propio servicio.
- Discrepancias con la tesis: recomendaciones sin Groq y año calendario.
- 386 pruebas, 15 servicios, volumen de código actualizado.
</commit_message>
<xml_diff>
--- a/defensa_final/slides/FreelanceControl_Defensa_Final.pptx
+++ b/defensa_final/slides/FreelanceControl_Defensa_Final.pptx
@@ -5106,7 +5106,7 @@
                 <a:ea typeface="Calibri" pitchFamily="34" charset="-122"/>
                 <a:cs typeface="Calibri" pitchFamily="34" charset="-120"/>
               </a:rPr>
-              <a:t>Facturación móvil de 12 meses contra el límite de la categoría</a:t>
+              <a:t>Año en curso + proyección hasta diciembre contra el límite de la categoría</a:t>
             </a:r>
             <a:endParaRPr lang="en-US" sz="1150" dirty="0"/>
           </a:p>
@@ -7338,7 +7338,7 @@
                 <a:ea typeface="Calibri" pitchFamily="34" charset="-122"/>
                 <a:cs typeface="Calibri" pitchFamily="34" charset="-120"/>
               </a:rPr>
-              <a:t>pytest — 115 pruebas</a:t>
+              <a:t>pytest — 386 pruebas</a:t>
             </a:r>
             <a:endParaRPr lang="en-US" sz="1150" dirty="0"/>
           </a:p>
@@ -8060,7 +8060,7 @@
                 <a:ea typeface="Calibri" pitchFamily="34" charset="-122"/>
                 <a:cs typeface="Calibri" pitchFamily="34" charset="-120"/>
               </a:rPr>
-              <a:t>9 archivos</a:t>
+              <a:t>15 archivos</a:t>
             </a:r>
             <a:endParaRPr lang="en-US" sz="1150" dirty="0"/>
           </a:p>
@@ -8421,7 +8421,7 @@
                 <a:ea typeface="Calibri" pitchFamily="34" charset="-122"/>
                 <a:cs typeface="Calibri" pitchFamily="34" charset="-120"/>
               </a:rPr>
-              <a:t>115 pruebas contra SQLite en memoria, sin levantar HTTP. 35 segundos.</a:t>
+              <a:t>386 pruebas contra SQLite en memoria, sin levantar HTTP. Unos 2 minutos.</a:t>
             </a:r>
             <a:endParaRPr lang="en-US" sz="1100" dirty="0"/>
           </a:p>
@@ -8899,12 +8899,12 @@
             <a:tbl>
               <a:tblPr/>
               <a:tblGrid>
-                <a:gridCol w="3291840"/>
+                <a:gridCol w="3108960"/>
                 <a:gridCol w="2194560"/>
-                <a:gridCol w="2743200"/>
-                <a:gridCol w="2651760"/>
+                <a:gridCol w="3017520"/>
+                <a:gridCol w="2560320"/>
               </a:tblGrid>
-              <a:tr h="329184">
+              <a:tr h="310896">
                 <a:tc>
                   <a:txBody>
                     <a:bodyPr/>
@@ -9178,7 +9178,7 @@
                   </a:tcPr>
                 </a:tc>
               </a:tr>
-              <a:tr h="329184">
+              <a:tr h="310896">
                 <a:tc>
                   <a:txBody>
                     <a:bodyPr/>
@@ -9452,7 +9452,7 @@
                   </a:tcPr>
                 </a:tc>
               </a:tr>
-              <a:tr h="329184">
+              <a:tr h="310896">
                 <a:tc>
                   <a:txBody>
                     <a:bodyPr/>
@@ -9726,7 +9726,7 @@
                   </a:tcPr>
                 </a:tc>
               </a:tr>
-              <a:tr h="329184">
+              <a:tr h="310896">
                 <a:tc>
                   <a:txBody>
                     <a:bodyPr/>
@@ -10000,7 +10000,7 @@
                   </a:tcPr>
                 </a:tc>
               </a:tr>
-              <a:tr h="329184">
+              <a:tr h="310896">
                 <a:tc>
                   <a:txBody>
                     <a:bodyPr/>
@@ -10274,7 +10274,7 @@
                   </a:tcPr>
                 </a:tc>
               </a:tr>
-              <a:tr h="329184">
+              <a:tr h="310896">
                 <a:tc>
                   <a:txBody>
                     <a:bodyPr/>
@@ -10548,7 +10548,7 @@
                   </a:tcPr>
                 </a:tc>
               </a:tr>
-              <a:tr h="329184">
+              <a:tr h="310896">
                 <a:tc>
                   <a:txBody>
                     <a:bodyPr/>
@@ -10822,7 +10822,7 @@
                   </a:tcPr>
                 </a:tc>
               </a:tr>
-              <a:tr h="329184">
+              <a:tr h="310896">
                 <a:tc>
                   <a:txBody>
                     <a:bodyPr/>
@@ -11096,7 +11096,7 @@
                   </a:tcPr>
                 </a:tc>
               </a:tr>
-              <a:tr h="329184">
+              <a:tr h="310896">
                 <a:tc>
                   <a:txBody>
                     <a:bodyPr/>
@@ -11370,7 +11370,7 @@
                   </a:tcPr>
                 </a:tc>
               </a:tr>
-              <a:tr h="329184">
+              <a:tr h="310896">
                 <a:tc>
                   <a:txBody>
                     <a:bodyPr/>
@@ -11644,7 +11644,7 @@
                   </a:tcPr>
                 </a:tc>
               </a:tr>
-              <a:tr h="329184">
+              <a:tr h="310896">
                 <a:tc>
                   <a:txBody>
                     <a:bodyPr/>
@@ -11662,7 +11662,7 @@
                           <a:ea typeface="Calibri" pitchFamily="34" charset="-122"/>
                           <a:cs typeface="Calibri" pitchFamily="34" charset="-120"/>
                         </a:rPr>
-                        <a:t>Resumen y recomendaciones</a:t>
+                        <a:t>Resumen IA</a:t>
                       </a:r>
                       <a:endParaRPr lang="en-US" sz="1200" dirty="0">
                         <a:latin typeface="Calibri" charset="0"/>
@@ -11918,7 +11918,7 @@
                   </a:tcPr>
                 </a:tc>
               </a:tr>
-              <a:tr h="329184">
+              <a:tr h="310896">
                 <a:tc>
                   <a:txBody>
                     <a:bodyPr/>
@@ -11936,7 +11936,7 @@
                           <a:ea typeface="Calibri" pitchFamily="34" charset="-122"/>
                           <a:cs typeface="Calibri" pitchFamily="34" charset="-120"/>
                         </a:rPr>
-                        <a:t>Reporte PDF</a:t>
+                        <a:t>Recomendaciones</a:t>
                       </a:r>
                       <a:endParaRPr lang="en-US" sz="1200" dirty="0">
                         <a:latin typeface="Calibri" charset="0"/>
@@ -12004,7 +12004,7 @@
                           <a:ea typeface="Consolas" pitchFamily="34" charset="-122"/>
                           <a:cs typeface="Consolas" pitchFamily="34" charset="-120"/>
                         </a:rPr>
-                        <a:t>reportes</a:t>
+                        <a:t>recomendaciones</a:t>
                       </a:r>
                       <a:endParaRPr lang="en-US" sz="1200" dirty="0">
                         <a:latin typeface="Consolas" charset="0"/>
@@ -12072,7 +12072,7 @@
                           <a:ea typeface="Consolas" pitchFamily="34" charset="-122"/>
                           <a:cs typeface="Consolas" pitchFamily="34" charset="-120"/>
                         </a:rPr>
-                        <a:t>reportes_service</a:t>
+                        <a:t>recomendaciones_service</a:t>
                       </a:r>
                       <a:endParaRPr lang="en-US" sz="1200" dirty="0">
                         <a:latin typeface="Consolas" charset="0"/>
@@ -12192,6 +12192,280 @@
                   </a:tcPr>
                 </a:tc>
               </a:tr>
+              <a:tr h="310896">
+                <a:tc>
+                  <a:txBody>
+                    <a:bodyPr/>
+                    <a:lstStyle/>
+                    <a:p>
+                      <a:pPr indent="0" marL="0">
+                        <a:buNone/>
+                      </a:pPr>
+                      <a:r>
+                        <a:rPr lang="en-US" sz="1200" dirty="0">
+                          <a:solidFill>
+                            <a:srgbClr val="16222E"/>
+                          </a:solidFill>
+                          <a:latin typeface="Calibri" pitchFamily="34" charset="0"/>
+                          <a:ea typeface="Calibri" pitchFamily="34" charset="-122"/>
+                          <a:cs typeface="Calibri" pitchFamily="34" charset="-120"/>
+                        </a:rPr>
+                        <a:t>Reporte PDF</a:t>
+                      </a:r>
+                      <a:endParaRPr lang="en-US" sz="1200" dirty="0">
+                        <a:latin typeface="Calibri" charset="0"/>
+                        <a:ea typeface="Calibri" charset="0"/>
+                        <a:cs typeface="Calibri" charset="0"/>
+                      </a:endParaRPr>
+                    </a:p>
+                  </a:txBody>
+                  <a:tcPr marL="91440" marR="91440" marT="45720" marB="45720" anchor="ctr">
+                    <a:lnL w="6350" cap="flat" cmpd="sng" algn="ctr">
+                      <a:solidFill>
+                        <a:srgbClr val="DCE4EC"/>
+                      </a:solidFill>
+                      <a:prstDash val="solid"/>
+                      <a:round/>
+                      <a:headEnd type="none" w="med" len="med"/>
+                      <a:tailEnd type="none" w="med" len="med"/>
+                    </a:lnL>
+                    <a:lnR w="6350" cap="flat" cmpd="sng" algn="ctr">
+                      <a:solidFill>
+                        <a:srgbClr val="DCE4EC"/>
+                      </a:solidFill>
+                      <a:prstDash val="solid"/>
+                      <a:round/>
+                      <a:headEnd type="none" w="med" len="med"/>
+                      <a:tailEnd type="none" w="med" len="med"/>
+                    </a:lnR>
+                    <a:lnT w="6350" cap="flat" cmpd="sng" algn="ctr">
+                      <a:solidFill>
+                        <a:srgbClr val="DCE4EC"/>
+                      </a:solidFill>
+                      <a:prstDash val="solid"/>
+                      <a:round/>
+                      <a:headEnd type="none" w="med" len="med"/>
+                      <a:tailEnd type="none" w="med" len="med"/>
+                    </a:lnT>
+                    <a:lnB w="6350" cap="flat" cmpd="sng" algn="ctr">
+                      <a:solidFill>
+                        <a:srgbClr val="DCE4EC"/>
+                      </a:solidFill>
+                      <a:prstDash val="solid"/>
+                      <a:round/>
+                      <a:headEnd type="none" w="med" len="med"/>
+                      <a:tailEnd type="none" w="med" len="med"/>
+                    </a:lnB>
+                    <a:solidFill>
+                      <a:srgbClr val="EDF2F7"/>
+                    </a:solidFill>
+                  </a:tcPr>
+                </a:tc>
+                <a:tc>
+                  <a:txBody>
+                    <a:bodyPr/>
+                    <a:lstStyle/>
+                    <a:p>
+                      <a:pPr indent="0" marL="0">
+                        <a:buNone/>
+                      </a:pPr>
+                      <a:r>
+                        <a:rPr lang="en-US" sz="1200" dirty="0">
+                          <a:solidFill>
+                            <a:srgbClr val="4A5A68"/>
+                          </a:solidFill>
+                          <a:latin typeface="Consolas" pitchFamily="34" charset="0"/>
+                          <a:ea typeface="Consolas" pitchFamily="34" charset="-122"/>
+                          <a:cs typeface="Consolas" pitchFamily="34" charset="-120"/>
+                        </a:rPr>
+                        <a:t>reportes</a:t>
+                      </a:r>
+                      <a:endParaRPr lang="en-US" sz="1200" dirty="0">
+                        <a:latin typeface="Consolas" charset="0"/>
+                        <a:ea typeface="Consolas" charset="0"/>
+                        <a:cs typeface="Consolas" charset="0"/>
+                      </a:endParaRPr>
+                    </a:p>
+                  </a:txBody>
+                  <a:tcPr marL="91440" marR="91440" marT="45720" marB="45720" anchor="ctr">
+                    <a:lnL w="6350" cap="flat" cmpd="sng" algn="ctr">
+                      <a:solidFill>
+                        <a:srgbClr val="DCE4EC"/>
+                      </a:solidFill>
+                      <a:prstDash val="solid"/>
+                      <a:round/>
+                      <a:headEnd type="none" w="med" len="med"/>
+                      <a:tailEnd type="none" w="med" len="med"/>
+                    </a:lnL>
+                    <a:lnR w="6350" cap="flat" cmpd="sng" algn="ctr">
+                      <a:solidFill>
+                        <a:srgbClr val="DCE4EC"/>
+                      </a:solidFill>
+                      <a:prstDash val="solid"/>
+                      <a:round/>
+                      <a:headEnd type="none" w="med" len="med"/>
+                      <a:tailEnd type="none" w="med" len="med"/>
+                    </a:lnR>
+                    <a:lnT w="6350" cap="flat" cmpd="sng" algn="ctr">
+                      <a:solidFill>
+                        <a:srgbClr val="DCE4EC"/>
+                      </a:solidFill>
+                      <a:prstDash val="solid"/>
+                      <a:round/>
+                      <a:headEnd type="none" w="med" len="med"/>
+                      <a:tailEnd type="none" w="med" len="med"/>
+                    </a:lnT>
+                    <a:lnB w="6350" cap="flat" cmpd="sng" algn="ctr">
+                      <a:solidFill>
+                        <a:srgbClr val="DCE4EC"/>
+                      </a:solidFill>
+                      <a:prstDash val="solid"/>
+                      <a:round/>
+                      <a:headEnd type="none" w="med" len="med"/>
+                      <a:tailEnd type="none" w="med" len="med"/>
+                    </a:lnB>
+                    <a:solidFill>
+                      <a:srgbClr val="EDF2F7"/>
+                    </a:solidFill>
+                  </a:tcPr>
+                </a:tc>
+                <a:tc>
+                  <a:txBody>
+                    <a:bodyPr/>
+                    <a:lstStyle/>
+                    <a:p>
+                      <a:pPr indent="0" marL="0">
+                        <a:buNone/>
+                      </a:pPr>
+                      <a:r>
+                        <a:rPr lang="en-US" sz="1200" dirty="0">
+                          <a:solidFill>
+                            <a:srgbClr val="4A5A68"/>
+                          </a:solidFill>
+                          <a:latin typeface="Consolas" pitchFamily="34" charset="0"/>
+                          <a:ea typeface="Consolas" pitchFamily="34" charset="-122"/>
+                          <a:cs typeface="Consolas" pitchFamily="34" charset="-120"/>
+                        </a:rPr>
+                        <a:t>reportes_service</a:t>
+                      </a:r>
+                      <a:endParaRPr lang="en-US" sz="1200" dirty="0">
+                        <a:latin typeface="Consolas" charset="0"/>
+                        <a:ea typeface="Consolas" charset="0"/>
+                        <a:cs typeface="Consolas" charset="0"/>
+                      </a:endParaRPr>
+                    </a:p>
+                  </a:txBody>
+                  <a:tcPr marL="91440" marR="91440" marT="45720" marB="45720" anchor="ctr">
+                    <a:lnL w="6350" cap="flat" cmpd="sng" algn="ctr">
+                      <a:solidFill>
+                        <a:srgbClr val="DCE4EC"/>
+                      </a:solidFill>
+                      <a:prstDash val="solid"/>
+                      <a:round/>
+                      <a:headEnd type="none" w="med" len="med"/>
+                      <a:tailEnd type="none" w="med" len="med"/>
+                    </a:lnL>
+                    <a:lnR w="6350" cap="flat" cmpd="sng" algn="ctr">
+                      <a:solidFill>
+                        <a:srgbClr val="DCE4EC"/>
+                      </a:solidFill>
+                      <a:prstDash val="solid"/>
+                      <a:round/>
+                      <a:headEnd type="none" w="med" len="med"/>
+                      <a:tailEnd type="none" w="med" len="med"/>
+                    </a:lnR>
+                    <a:lnT w="6350" cap="flat" cmpd="sng" algn="ctr">
+                      <a:solidFill>
+                        <a:srgbClr val="DCE4EC"/>
+                      </a:solidFill>
+                      <a:prstDash val="solid"/>
+                      <a:round/>
+                      <a:headEnd type="none" w="med" len="med"/>
+                      <a:tailEnd type="none" w="med" len="med"/>
+                    </a:lnT>
+                    <a:lnB w="6350" cap="flat" cmpd="sng" algn="ctr">
+                      <a:solidFill>
+                        <a:srgbClr val="DCE4EC"/>
+                      </a:solidFill>
+                      <a:prstDash val="solid"/>
+                      <a:round/>
+                      <a:headEnd type="none" w="med" len="med"/>
+                      <a:tailEnd type="none" w="med" len="med"/>
+                    </a:lnB>
+                    <a:solidFill>
+                      <a:srgbClr val="EDF2F7"/>
+                    </a:solidFill>
+                  </a:tcPr>
+                </a:tc>
+                <a:tc>
+                  <a:txBody>
+                    <a:bodyPr/>
+                    <a:lstStyle/>
+                    <a:p>
+                      <a:pPr indent="0" marL="0">
+                        <a:buNone/>
+                      </a:pPr>
+                      <a:r>
+                        <a:rPr lang="en-US" sz="1200" dirty="0">
+                          <a:solidFill>
+                            <a:srgbClr val="4A5A68"/>
+                          </a:solidFill>
+                          <a:latin typeface="Consolas" pitchFamily="34" charset="0"/>
+                          <a:ea typeface="Consolas" pitchFamily="34" charset="-122"/>
+                          <a:cs typeface="Consolas" pitchFamily="34" charset="-120"/>
+                        </a:rPr>
+                        <a:t>—</a:t>
+                      </a:r>
+                      <a:endParaRPr lang="en-US" sz="1200" dirty="0">
+                        <a:latin typeface="Consolas" charset="0"/>
+                        <a:ea typeface="Consolas" charset="0"/>
+                        <a:cs typeface="Consolas" charset="0"/>
+                      </a:endParaRPr>
+                    </a:p>
+                  </a:txBody>
+                  <a:tcPr marL="91440" marR="91440" marT="45720" marB="45720" anchor="ctr">
+                    <a:lnL w="6350" cap="flat" cmpd="sng" algn="ctr">
+                      <a:solidFill>
+                        <a:srgbClr val="DCE4EC"/>
+                      </a:solidFill>
+                      <a:prstDash val="solid"/>
+                      <a:round/>
+                      <a:headEnd type="none" w="med" len="med"/>
+                      <a:tailEnd type="none" w="med" len="med"/>
+                    </a:lnL>
+                    <a:lnR w="6350" cap="flat" cmpd="sng" algn="ctr">
+                      <a:solidFill>
+                        <a:srgbClr val="DCE4EC"/>
+                      </a:solidFill>
+                      <a:prstDash val="solid"/>
+                      <a:round/>
+                      <a:headEnd type="none" w="med" len="med"/>
+                      <a:tailEnd type="none" w="med" len="med"/>
+                    </a:lnR>
+                    <a:lnT w="6350" cap="flat" cmpd="sng" algn="ctr">
+                      <a:solidFill>
+                        <a:srgbClr val="DCE4EC"/>
+                      </a:solidFill>
+                      <a:prstDash val="solid"/>
+                      <a:round/>
+                      <a:headEnd type="none" w="med" len="med"/>
+                      <a:tailEnd type="none" w="med" len="med"/>
+                    </a:lnT>
+                    <a:lnB w="6350" cap="flat" cmpd="sng" algn="ctr">
+                      <a:solidFill>
+                        <a:srgbClr val="DCE4EC"/>
+                      </a:solidFill>
+                      <a:prstDash val="solid"/>
+                      <a:round/>
+                      <a:headEnd type="none" w="med" len="med"/>
+                      <a:tailEnd type="none" w="med" len="med"/>
+                    </a:lnB>
+                    <a:solidFill>
+                      <a:srgbClr val="EDF2F7"/>
+                    </a:solidFill>
+                  </a:tcPr>
+                </a:tc>
+              </a:tr>
             </a:tbl>
           </a:graphicData>
         </a:graphic>
@@ -12229,7 +12503,7 @@
                 <a:ea typeface="Calibri" pitchFamily="34" charset="-122"/>
                 <a:cs typeface="Calibri" pitchFamily="34" charset="-120"/>
               </a:rPr>
-              <a:t>6.140 líneas de backend  ·  4.609 de frontend  ·  115 pruebas  ·  9 tablas  ·  13 pantallas</a:t>
+              <a:t>8.063 líneas de backend  ·  5.344 de frontend  ·  386 pruebas  ·  9 tablas  ·  13 pantallas</a:t>
             </a:r>
             <a:endParaRPr lang="en-US" sz="1300" dirty="0"/>
           </a:p>
@@ -14573,7 +14847,7 @@
                 <a:ea typeface="Consolas" pitchFamily="34" charset="-122"/>
                 <a:cs typeface="Consolas" pitchFamily="34" charset="-120"/>
               </a:rPr>
-              <a:t>app/services/ml_service.py:728</a:t>
+              <a:t>app/services/ml_service.py:726</a:t>
             </a:r>
             <a:endParaRPr lang="en-US" sz="1050" dirty="0"/>
           </a:p>
@@ -17546,7 +17820,7 @@
                 <a:ea typeface="Consolas" pitchFamily="34" charset="-122"/>
                 <a:cs typeface="Consolas" pitchFamily="34" charset="-120"/>
               </a:rPr>
-              <a:t>ia_service.py:276</a:t>
+              <a:t>ia_service.py:409</a:t>
             </a:r>
             <a:endParaRPr lang="en-US" sz="1000" dirty="0"/>
           </a:p>
@@ -20651,7 +20925,7 @@
                 <a:ea typeface="Consolas" pitchFamily="34" charset="-122"/>
                 <a:cs typeface="Consolas" pitchFamily="34" charset="-120"/>
               </a:rPr>
-              <a:t>app/services/ml_service.py:826  ·  _confianza_svm()</a:t>
+              <a:t>app/services/ml_service.py:830  ·  _confianza_svm()</a:t>
             </a:r>
             <a:endParaRPr lang="en-US" sz="1050" dirty="0"/>
           </a:p>
@@ -23795,7 +24069,7 @@
                 <a:ea typeface="Georgia" pitchFamily="34" charset="-122"/>
                 <a:cs typeface="Georgia" pitchFamily="34" charset="-120"/>
               </a:rPr>
-              <a:t>115</a:t>
+              <a:t>386</a:t>
             </a:r>
             <a:endParaRPr lang="en-US" sz="2600" dirty="0"/>
           </a:p>
@@ -25309,7 +25583,7 @@
                 <a:ea typeface="Calibri" pitchFamily="34" charset="-122"/>
                 <a:cs typeface="Calibri" pitchFamily="34" charset="-120"/>
               </a:rPr>
-              <a:t>Idempotencia: cada condición tiene una huella estable (tipo + monto). Una alerta que el usuario marcó como resuelta no se regenera en la corrida siguiente.</a:t>
+              <a:t>Idempotencia: cada condición tiene una huella estable (el registro que la originó). Una alerta que el usuario marcó como resuelta no se regenera en la corrida siguiente.</a:t>
             </a:r>
             <a:endParaRPr lang="en-US" sz="1200" dirty="0"/>
           </a:p>
@@ -27338,7 +27612,7 @@
                 <a:ea typeface="Consolas" pitchFamily="34" charset="-122"/>
                 <a:cs typeface="Consolas" pitchFamily="34" charset="-120"/>
               </a:rPr>
-              <a:t>ml_service.py:728</a:t>
+              <a:t>ml_service.py:726</a:t>
             </a:r>
             <a:endParaRPr lang="en-US" sz="1050" dirty="0"/>
           </a:p>
@@ -27438,7 +27712,7 @@
                 <a:ea typeface="Consolas" pitchFamily="34" charset="-122"/>
                 <a:cs typeface="Consolas" pitchFamily="34" charset="-120"/>
               </a:rPr>
-              <a:t>ml_service.py:713</a:t>
+              <a:t>ml_service.py:711</a:t>
             </a:r>
             <a:endParaRPr lang="en-US" sz="1050" dirty="0"/>
           </a:p>
@@ -27538,7 +27812,7 @@
                 <a:ea typeface="Consolas" pitchFamily="34" charset="-122"/>
                 <a:cs typeface="Consolas" pitchFamily="34" charset="-120"/>
               </a:rPr>
-              <a:t>ml_service.py:826</a:t>
+              <a:t>ml_service.py:830</a:t>
             </a:r>
             <a:endParaRPr lang="en-US" sz="1050" dirty="0"/>
           </a:p>
@@ -27638,7 +27912,7 @@
                 <a:ea typeface="Consolas" pitchFamily="34" charset="-122"/>
                 <a:cs typeface="Consolas" pitchFamily="34" charset="-120"/>
               </a:rPr>
-              <a:t>prophet_service.py:91</a:t>
+              <a:t>prophet_service.py:179</a:t>
             </a:r>
             <a:endParaRPr lang="en-US" sz="1050" dirty="0"/>
           </a:p>
@@ -27838,7 +28112,7 @@
                 <a:ea typeface="Consolas" pitchFamily="34" charset="-122"/>
                 <a:cs typeface="Consolas" pitchFamily="34" charset="-120"/>
               </a:rPr>
-              <a:t>csv_service.py:581</a:t>
+              <a:t>csv_service.py:738</a:t>
             </a:r>
             <a:endParaRPr lang="en-US" sz="1050" dirty="0"/>
           </a:p>
@@ -27938,7 +28212,7 @@
                 <a:ea typeface="Consolas" pitchFamily="34" charset="-122"/>
                 <a:cs typeface="Consolas" pitchFamily="34" charset="-120"/>
               </a:rPr>
-              <a:t>ia_service.py:276</a:t>
+              <a:t>ia_service.py:409</a:t>
             </a:r>
             <a:endParaRPr lang="en-US" sz="1050" dirty="0"/>
           </a:p>
@@ -28038,7 +28312,7 @@
                 <a:ea typeface="Consolas" pitchFamily="34" charset="-122"/>
                 <a:cs typeface="Consolas" pitchFamily="34" charset="-120"/>
               </a:rPr>
-              <a:t>auditoria.py:48</a:t>
+              <a:t>auditoria.py:59</a:t>
             </a:r>
             <a:endParaRPr lang="en-US" sz="1050" dirty="0"/>
           </a:p>
@@ -28138,7 +28412,7 @@
                 <a:ea typeface="Consolas" pitchFamily="34" charset="-122"/>
                 <a:cs typeface="Consolas" pitchFamily="34" charset="-120"/>
               </a:rPr>
-              <a:t>auditoria.py:66</a:t>
+              <a:t>auditoria.py:77</a:t>
             </a:r>
             <a:endParaRPr lang="en-US" sz="1050" dirty="0"/>
           </a:p>
@@ -28238,7 +28512,7 @@
                 <a:ea typeface="Consolas" pitchFamily="34" charset="-122"/>
                 <a:cs typeface="Consolas" pitchFamily="34" charset="-120"/>
               </a:rPr>
-              <a:t>reportes_service.py:406</a:t>
+              <a:t>reportes_service.py:535</a:t>
             </a:r>
             <a:endParaRPr lang="en-US" sz="1050" dirty="0"/>
           </a:p>
@@ -28338,7 +28612,7 @@
                 <a:ea typeface="Consolas" pitchFamily="34" charset="-122"/>
                 <a:cs typeface="Consolas" pitchFamily="34" charset="-120"/>
               </a:rPr>
-              <a:t>monotributo_service.py:36</a:t>
+              <a:t>monotributo_service.py:66</a:t>
             </a:r>
             <a:endParaRPr lang="en-US" sz="1050" dirty="0"/>
           </a:p>

</xml_diff>

<commit_message>
docs(defensa): 387 pruebas en guion, arquitectura y diapositivas
</commit_message>
<xml_diff>
--- a/defensa_final/slides/FreelanceControl_Defensa_Final.pptx
+++ b/defensa_final/slides/FreelanceControl_Defensa_Final.pptx
@@ -7338,7 +7338,7 @@
                 <a:ea typeface="Calibri" pitchFamily="34" charset="-122"/>
                 <a:cs typeface="Calibri" pitchFamily="34" charset="-120"/>
               </a:rPr>
-              <a:t>pytest — 386 pruebas</a:t>
+              <a:t>pytest — 387 pruebas</a:t>
             </a:r>
             <a:endParaRPr lang="en-US" sz="1150" dirty="0"/>
           </a:p>
@@ -8421,7 +8421,7 @@
                 <a:ea typeface="Calibri" pitchFamily="34" charset="-122"/>
                 <a:cs typeface="Calibri" pitchFamily="34" charset="-120"/>
               </a:rPr>
-              <a:t>386 pruebas contra SQLite en memoria, sin levantar HTTP. Unos 2 minutos.</a:t>
+              <a:t>387 pruebas contra SQLite en memoria, sin levantar HTTP. Unos 2 minutos.</a:t>
             </a:r>
             <a:endParaRPr lang="en-US" sz="1100" dirty="0"/>
           </a:p>
@@ -12503,7 +12503,7 @@
                 <a:ea typeface="Calibri" pitchFamily="34" charset="-122"/>
                 <a:cs typeface="Calibri" pitchFamily="34" charset="-120"/>
               </a:rPr>
-              <a:t>8.063 líneas de backend  ·  5.344 de frontend  ·  386 pruebas  ·  9 tablas  ·  13 pantallas</a:t>
+              <a:t>8.063 líneas de backend  ·  5.344 de frontend  ·  387 pruebas  ·  9 tablas  ·  13 pantallas</a:t>
             </a:r>
             <a:endParaRPr lang="en-US" sz="1300" dirty="0"/>
           </a:p>
@@ -24069,7 +24069,7 @@
                 <a:ea typeface="Georgia" pitchFamily="34" charset="-122"/>
                 <a:cs typeface="Georgia" pitchFamily="34" charset="-120"/>
               </a:rPr>
-              <a:t>386</a:t>
+              <a:t>387</a:t>
             </a:r>
             <a:endParaRPr lang="en-US" sz="2600" dirty="0"/>
           </a:p>

</xml_diff>

<commit_message>
docs(defensa): guion de la demo con los datos de la defensa y 390 pruebas
La demo usa seed_demo_defensa.py y el extracto del 28/09 al 14/10: el
Dashboard arranca en octubre vacío, la vista previa muestra los repetidos,
la transferencia propia y la fila con fecha ilegible, y el Monotributo
queda en rojo con la categoría sugerida. Se corrige la advertencia sobre
el reentrenamiento (la corrección se aplica al instante; el modelo se
reentrena en segundo plano).
</commit_message>
<xml_diff>
--- a/defensa_final/slides/FreelanceControl_Defensa_Final.pptx
+++ b/defensa_final/slides/FreelanceControl_Defensa_Final.pptx
@@ -7338,7 +7338,7 @@
                 <a:ea typeface="Calibri" pitchFamily="34" charset="-122"/>
                 <a:cs typeface="Calibri" pitchFamily="34" charset="-120"/>
               </a:rPr>
-              <a:t>pytest — 387 pruebas</a:t>
+              <a:t>pytest — 390 pruebas</a:t>
             </a:r>
             <a:endParaRPr lang="en-US" sz="1150" dirty="0"/>
           </a:p>
@@ -8421,7 +8421,7 @@
                 <a:ea typeface="Calibri" pitchFamily="34" charset="-122"/>
                 <a:cs typeface="Calibri" pitchFamily="34" charset="-120"/>
               </a:rPr>
-              <a:t>387 pruebas contra SQLite en memoria, sin levantar HTTP. Unos 2 minutos.</a:t>
+              <a:t>390 pruebas contra SQLite en memoria, sin levantar HTTP. Unos 2 minutos.</a:t>
             </a:r>
             <a:endParaRPr lang="en-US" sz="1100" dirty="0"/>
           </a:p>
@@ -12503,7 +12503,7 @@
                 <a:ea typeface="Calibri" pitchFamily="34" charset="-122"/>
                 <a:cs typeface="Calibri" pitchFamily="34" charset="-120"/>
               </a:rPr>
-              <a:t>8.063 líneas de backend  ·  5.344 de frontend  ·  387 pruebas  ·  9 tablas  ·  13 pantallas</a:t>
+              <a:t>8.063 líneas de backend  ·  5.344 de frontend  ·  390 pruebas  ·  9 tablas  ·  13 pantallas</a:t>
             </a:r>
             <a:endParaRPr lang="en-US" sz="1300" dirty="0"/>
           </a:p>
@@ -24069,7 +24069,7 @@
                 <a:ea typeface="Georgia" pitchFamily="34" charset="-122"/>
                 <a:cs typeface="Georgia" pitchFamily="34" charset="-120"/>
               </a:rPr>
-              <a:t>387</a:t>
+              <a:t>390</a:t>
             </a:r>
             <a:endParaRPr lang="en-US" sz="2600" dirty="0"/>
           </a:p>

</xml_diff>

<commit_message>
docs(defensa): ensayo general — video institucional solo, recargar pestañas y diapositivas al día
- Bloque 3: se pasa solo el video institucional; los dos minutos que libera
  van al clasificador (4.2, con "servicio" 0,28 → 0,50 en vivo).
- Antes de entrar: abrir Docker Desktop y recargar cada pestaña después de
  importar el extracto (cada pantalla carga sus datos al abrirse).
- Diapositivas: Strategy con lo medido (SVM 76 % / NB 74 %), seguridad con
  "firmado no es cifrado" y sus límites, el recorrido de 8 pasos, el aviso
  en seis pantallas, el reloj del bloque 5 y los números de hoy.
- Arquitectura: referencias archivo:línea al día y la sección Strategy
  corregida.
</commit_message>
<xml_diff>
--- a/defensa_final/slides/FreelanceControl_Defensa_Final.pptx
+++ b/defensa_final/slides/FreelanceControl_Defensa_Final.pptx
@@ -4098,7 +4098,7 @@
                 <a:ea typeface="Calibri" pitchFamily="34" charset="-122"/>
                 <a:cs typeface="Calibri" pitchFamily="34" charset="-120"/>
               </a:rPr>
-              <a:t>VIDEO EXPLICATIVO</a:t>
+              <a:t>VIDEO INSTITUCIONAL</a:t>
             </a:r>
             <a:endParaRPr lang="en-US" sz="1400" dirty="0"/>
           </a:p>
@@ -4137,7 +4137,7 @@
                 <a:ea typeface="Georgia" pitchFamily="34" charset="-122"/>
                 <a:cs typeface="Georgia" pitchFamily="34" charset="-120"/>
               </a:rPr>
-              <a:t>El sistema, de principio a fin</a:t>
+              <a:t>El problema y la propuesta</a:t>
             </a:r>
             <a:endParaRPr lang="en-US" sz="4400" dirty="0"/>
           </a:p>
@@ -4176,7 +4176,7 @@
                 <a:ea typeface="Calibri" pitchFamily="34" charset="-122"/>
                 <a:cs typeface="Calibri" pitchFamily="34" charset="-120"/>
               </a:rPr>
-              <a:t>Recorrido del ciclo completo de uso, en el mismo orden en que fueron diagnosticados los problemas.</a:t>
+              <a:t>Por qué hace falta, qué resuelve y hasta dónde llega. Después, el sistema en vivo.</a:t>
             </a:r>
             <a:endParaRPr lang="en-US" sz="1700" dirty="0"/>
           </a:p>
@@ -4215,7 +4215,7 @@
                 <a:ea typeface="Georgia" pitchFamily="34" charset="-122"/>
                 <a:cs typeface="Georgia" pitchFamily="34" charset="-120"/>
               </a:rPr>
-              <a:t>▶   4 minutos</a:t>
+              <a:t>▶   1:43</a:t>
             </a:r>
             <a:endParaRPr lang="en-US" sz="2200" dirty="0"/>
           </a:p>
@@ -4403,7 +4403,7 @@
                 <a:ea typeface="Calibri" pitchFamily="34" charset="-122"/>
                 <a:cs typeface="Calibri" pitchFamily="34" charset="-120"/>
               </a:rPr>
-              <a:t>Bloque 4 · 10:00</a:t>
+              <a:t>Bloque 4 · 8:00</a:t>
             </a:r>
             <a:endParaRPr lang="en-US" sz="1050" dirty="0"/>
           </a:p>
@@ -4456,12 +4456,178 @@
         </p:nvSpPr>
         <p:spPr>
           <a:xfrm>
-            <a:off x="640080" y="1965960"/>
-            <a:ext cx="5257800" cy="1143000"/>
+            <a:off x="640080" y="1828800"/>
+            <a:ext cx="5257800" cy="896112"/>
           </a:xfrm>
           <a:prstGeom prst="roundRect">
             <a:avLst>
-              <a:gd name="adj" fmla="val 6400"/>
+              <a:gd name="adj" fmla="val 8163"/>
+            </a:avLst>
+          </a:prstGeom>
+          <a:solidFill>
+            <a:srgbClr val="14395E"/>
+          </a:solidFill>
+          <a:ln w="12700">
+            <a:solidFill>
+              <a:srgbClr val="5BB3C4"/>
+            </a:solidFill>
+            <a:prstDash val="solid"/>
+          </a:ln>
+        </p:spPr>
+      </p:sp>
+      <p:sp>
+        <p:nvSpPr>
+          <p:cNvPr id="6" name="Shape 4"/>
+          <p:cNvSpPr/>
+          <p:nvPr/>
+        </p:nvSpPr>
+        <p:spPr>
+          <a:xfrm>
+            <a:off x="868680" y="2020824"/>
+            <a:ext cx="512064" cy="512064"/>
+          </a:xfrm>
+          <a:prstGeom prst="roundRect">
+            <a:avLst>
+              <a:gd name="adj" fmla="val 50000"/>
+            </a:avLst>
+          </a:prstGeom>
+          <a:solidFill>
+            <a:srgbClr val="5BB3C4"/>
+          </a:solidFill>
+          <a:ln/>
+        </p:spPr>
+      </p:sp>
+      <p:sp>
+        <p:nvSpPr>
+          <p:cNvPr id="7" name="Text 5"/>
+          <p:cNvSpPr/>
+          <p:nvPr/>
+        </p:nvSpPr>
+        <p:spPr>
+          <a:xfrm>
+            <a:off x="868680" y="2020824"/>
+            <a:ext cx="512064" cy="512064"/>
+          </a:xfrm>
+          <a:prstGeom prst="rect">
+            <a:avLst/>
+          </a:prstGeom>
+          <a:noFill/>
+          <a:ln/>
+        </p:spPr>
+        <p:txBody>
+          <a:bodyPr wrap="square" rtlCol="0" anchor="ctr"/>
+          <a:lstStyle/>
+          <a:p>
+            <a:pPr algn="ctr" indent="0" marL="0">
+              <a:buNone/>
+            </a:pPr>
+            <a:r>
+              <a:rPr lang="en-US" sz="1800" b="1" dirty="0">
+                <a:solidFill>
+                  <a:srgbClr val="0D2B45"/>
+                </a:solidFill>
+                <a:latin typeface="Georgia" pitchFamily="34" charset="0"/>
+                <a:ea typeface="Georgia" pitchFamily="34" charset="-122"/>
+                <a:cs typeface="Georgia" pitchFamily="34" charset="-120"/>
+              </a:rPr>
+              <a:t>1</a:t>
+            </a:r>
+            <a:endParaRPr lang="en-US" sz="1800" dirty="0"/>
+          </a:p>
+        </p:txBody>
+      </p:sp>
+      <p:sp>
+        <p:nvSpPr>
+          <p:cNvPr id="8" name="Text 6"/>
+          <p:cNvSpPr/>
+          <p:nvPr/>
+        </p:nvSpPr>
+        <p:spPr>
+          <a:xfrm>
+            <a:off x="1536192" y="1901952"/>
+            <a:ext cx="4206240" cy="365760"/>
+          </a:xfrm>
+          <a:prstGeom prst="rect">
+            <a:avLst/>
+          </a:prstGeom>
+          <a:noFill/>
+          <a:ln/>
+        </p:spPr>
+        <p:txBody>
+          <a:bodyPr wrap="square" rtlCol="0" anchor="ctr"/>
+          <a:lstStyle/>
+          <a:p>
+            <a:pPr indent="0" marL="0">
+              <a:buNone/>
+            </a:pPr>
+            <a:r>
+              <a:rPr lang="en-US" sz="1500" b="1" dirty="0">
+                <a:solidFill>
+                  <a:srgbClr val="FFFFFF"/>
+                </a:solidFill>
+                <a:latin typeface="Georgia" pitchFamily="34" charset="0"/>
+                <a:ea typeface="Georgia" pitchFamily="34" charset="-122"/>
+                <a:cs typeface="Georgia" pitchFamily="34" charset="-120"/>
+              </a:rPr>
+              <a:t>Panel principal</a:t>
+            </a:r>
+            <a:endParaRPr lang="en-US" sz="1500" dirty="0"/>
+          </a:p>
+        </p:txBody>
+      </p:sp>
+      <p:sp>
+        <p:nvSpPr>
+          <p:cNvPr id="9" name="Text 7"/>
+          <p:cNvSpPr/>
+          <p:nvPr/>
+        </p:nvSpPr>
+        <p:spPr>
+          <a:xfrm>
+            <a:off x="1536192" y="2267712"/>
+            <a:ext cx="4206240" cy="384048"/>
+          </a:xfrm>
+          <a:prstGeom prst="rect">
+            <a:avLst/>
+          </a:prstGeom>
+          <a:noFill/>
+          <a:ln/>
+        </p:spPr>
+        <p:txBody>
+          <a:bodyPr wrap="square" rtlCol="0" anchor="ctr"/>
+          <a:lstStyle/>
+          <a:p>
+            <a:pPr indent="0" marL="0">
+              <a:buNone/>
+            </a:pPr>
+            <a:r>
+              <a:rPr lang="en-US" sz="1100" dirty="0">
+                <a:solidFill>
+                  <a:srgbClr val="CADCFC"/>
+                </a:solidFill>
+                <a:latin typeface="Calibri" pitchFamily="34" charset="0"/>
+                <a:ea typeface="Calibri" pitchFamily="34" charset="-122"/>
+                <a:cs typeface="Calibri" pitchFamily="34" charset="-120"/>
+              </a:rPr>
+              <a:t>El mes, la proyección y la recomendación en una pantalla</a:t>
+            </a:r>
+            <a:endParaRPr lang="en-US" sz="1100" dirty="0"/>
+          </a:p>
+        </p:txBody>
+      </p:sp>
+      <p:sp>
+        <p:nvSpPr>
+          <p:cNvPr id="10" name="Shape 8"/>
+          <p:cNvSpPr/>
+          <p:nvPr/>
+        </p:nvSpPr>
+        <p:spPr>
+          <a:xfrm>
+            <a:off x="6217920" y="1828800"/>
+            <a:ext cx="5257800" cy="896112"/>
+          </a:xfrm>
+          <a:prstGeom prst="roundRect">
+            <a:avLst>
+              <a:gd name="adj" fmla="val 8163"/>
             </a:avLst>
           </a:prstGeom>
           <a:solidFill>
@@ -4477,14 +4643,14 @@
       </p:sp>
       <p:sp>
         <p:nvSpPr>
-          <p:cNvPr id="6" name="Shape 4"/>
-          <p:cNvSpPr/>
-          <p:nvPr/>
-        </p:nvSpPr>
-        <p:spPr>
-          <a:xfrm>
-            <a:off x="896112" y="2267712"/>
-            <a:ext cx="548640" cy="548640"/>
+          <p:cNvPr id="11" name="Shape 9"/>
+          <p:cNvSpPr/>
+          <p:nvPr/>
+        </p:nvSpPr>
+        <p:spPr>
+          <a:xfrm>
+            <a:off x="6446520" y="2020824"/>
+            <a:ext cx="512064" cy="512064"/>
           </a:xfrm>
           <a:prstGeom prst="roundRect">
             <a:avLst>
@@ -4499,14 +4665,14 @@
       </p:sp>
       <p:sp>
         <p:nvSpPr>
-          <p:cNvPr id="7" name="Text 5"/>
-          <p:cNvSpPr/>
-          <p:nvPr/>
-        </p:nvSpPr>
-        <p:spPr>
-          <a:xfrm>
-            <a:off x="896112" y="2267712"/>
-            <a:ext cx="548640" cy="548640"/>
+          <p:cNvPr id="12" name="Text 10"/>
+          <p:cNvSpPr/>
+          <p:nvPr/>
+        </p:nvSpPr>
+        <p:spPr>
+          <a:xfrm>
+            <a:off x="6446520" y="2020824"/>
+            <a:ext cx="512064" cy="512064"/>
           </a:xfrm>
           <a:prstGeom prst="rect">
             <a:avLst/>
@@ -4522,7 +4688,7 @@
               <a:buNone/>
             </a:pPr>
             <a:r>
-              <a:rPr lang="en-US" sz="2000" b="1" dirty="0">
+              <a:rPr lang="en-US" sz="1800" b="1" dirty="0">
                 <a:solidFill>
                   <a:srgbClr val="0D2B45"/>
                 </a:solidFill>
@@ -4530,38 +4696,38 @@
                 <a:ea typeface="Georgia" pitchFamily="34" charset="-122"/>
                 <a:cs typeface="Georgia" pitchFamily="34" charset="-120"/>
               </a:rPr>
-              <a:t>1</a:t>
-            </a:r>
-            <a:endParaRPr lang="en-US" sz="2000" dirty="0"/>
-          </a:p>
-        </p:txBody>
-      </p:sp>
-      <p:sp>
-        <p:nvSpPr>
-          <p:cNvPr id="8" name="Text 6"/>
-          <p:cNvSpPr/>
-          <p:nvPr/>
-        </p:nvSpPr>
-        <p:spPr>
-          <a:xfrm>
-            <a:off x="1600200" y="2148840"/>
-            <a:ext cx="4114800" cy="411480"/>
-          </a:xfrm>
-          <a:prstGeom prst="rect">
-            <a:avLst/>
-          </a:prstGeom>
-          <a:noFill/>
-          <a:ln/>
-        </p:spPr>
-        <p:txBody>
-          <a:bodyPr wrap="square" rtlCol="0" anchor="ctr"/>
-          <a:lstStyle/>
-          <a:p>
-            <a:pPr indent="0" marL="0">
-              <a:buNone/>
-            </a:pPr>
-            <a:r>
-              <a:rPr lang="en-US" sz="1550" b="1" dirty="0">
+              <a:t>2</a:t>
+            </a:r>
+            <a:endParaRPr lang="en-US" sz="1800" dirty="0"/>
+          </a:p>
+        </p:txBody>
+      </p:sp>
+      <p:sp>
+        <p:nvSpPr>
+          <p:cNvPr id="13" name="Text 11"/>
+          <p:cNvSpPr/>
+          <p:nvPr/>
+        </p:nvSpPr>
+        <p:spPr>
+          <a:xfrm>
+            <a:off x="7114032" y="1901952"/>
+            <a:ext cx="4206240" cy="365760"/>
+          </a:xfrm>
+          <a:prstGeom prst="rect">
+            <a:avLst/>
+          </a:prstGeom>
+          <a:noFill/>
+          <a:ln/>
+        </p:spPr>
+        <p:txBody>
+          <a:bodyPr wrap="square" rtlCol="0" anchor="ctr"/>
+          <a:lstStyle/>
+          <a:p>
+            <a:pPr indent="0" marL="0">
+              <a:buNone/>
+            </a:pPr>
+            <a:r>
+              <a:rPr lang="en-US" sz="1500" b="1" dirty="0">
                 <a:solidFill>
                   <a:srgbClr val="FFFFFF"/>
                 </a:solidFill>
@@ -4571,36 +4737,36 @@
               </a:rPr>
               <a:t>Clasificador de gastos</a:t>
             </a:r>
-            <a:endParaRPr lang="en-US" sz="1550" dirty="0"/>
-          </a:p>
-        </p:txBody>
-      </p:sp>
-      <p:sp>
-        <p:nvSpPr>
-          <p:cNvPr id="9" name="Text 7"/>
-          <p:cNvSpPr/>
-          <p:nvPr/>
-        </p:nvSpPr>
-        <p:spPr>
-          <a:xfrm>
-            <a:off x="1600200" y="2560320"/>
-            <a:ext cx="4114800" cy="457200"/>
-          </a:xfrm>
-          <a:prstGeom prst="rect">
-            <a:avLst/>
-          </a:prstGeom>
-          <a:noFill/>
-          <a:ln/>
-        </p:spPr>
-        <p:txBody>
-          <a:bodyPr wrap="square" rtlCol="0" anchor="ctr"/>
-          <a:lstStyle/>
-          <a:p>
-            <a:pPr indent="0" marL="0">
-              <a:buNone/>
-            </a:pPr>
-            <a:r>
-              <a:rPr lang="en-US" sz="1150" dirty="0">
+            <a:endParaRPr lang="en-US" sz="1500" dirty="0"/>
+          </a:p>
+        </p:txBody>
+      </p:sp>
+      <p:sp>
+        <p:nvSpPr>
+          <p:cNvPr id="14" name="Text 12"/>
+          <p:cNvSpPr/>
+          <p:nvPr/>
+        </p:nvSpPr>
+        <p:spPr>
+          <a:xfrm>
+            <a:off x="7114032" y="2267712"/>
+            <a:ext cx="4206240" cy="384048"/>
+          </a:xfrm>
+          <a:prstGeom prst="rect">
+            <a:avLst/>
+          </a:prstGeom>
+          <a:noFill/>
+          <a:ln/>
+        </p:spPr>
+        <p:txBody>
+          <a:bodyPr wrap="square" rtlCol="0" anchor="ctr"/>
+          <a:lstStyle/>
+          <a:p>
+            <a:pPr indent="0" marL="0">
+              <a:buNone/>
+            </a:pPr>
+            <a:r>
+              <a:rPr lang="en-US" sz="1100" dirty="0">
                 <a:solidFill>
                   <a:srgbClr val="CADCFC"/>
                 </a:solidFill>
@@ -4610,24 +4776,24 @@
               </a:rPr>
               <a:t>Sugerencia automática, umbral de confianza y aprendizaje por corrección</a:t>
             </a:r>
-            <a:endParaRPr lang="en-US" sz="1150" dirty="0"/>
-          </a:p>
-        </p:txBody>
-      </p:sp>
-      <p:sp>
-        <p:nvSpPr>
-          <p:cNvPr id="10" name="Shape 8"/>
-          <p:cNvSpPr/>
-          <p:nvPr/>
-        </p:nvSpPr>
-        <p:spPr>
-          <a:xfrm>
-            <a:off x="6217920" y="1965960"/>
-            <a:ext cx="5257800" cy="1143000"/>
+            <a:endParaRPr lang="en-US" sz="1100" dirty="0"/>
+          </a:p>
+        </p:txBody>
+      </p:sp>
+      <p:sp>
+        <p:nvSpPr>
+          <p:cNvPr id="15" name="Shape 13"/>
+          <p:cNvSpPr/>
+          <p:nvPr/>
+        </p:nvSpPr>
+        <p:spPr>
+          <a:xfrm>
+            <a:off x="640080" y="2852928"/>
+            <a:ext cx="5257800" cy="896112"/>
           </a:xfrm>
           <a:prstGeom prst="roundRect">
             <a:avLst>
-              <a:gd name="adj" fmla="val 6400"/>
+              <a:gd name="adj" fmla="val 8163"/>
             </a:avLst>
           </a:prstGeom>
           <a:solidFill>
@@ -4643,14 +4809,14 @@
       </p:sp>
       <p:sp>
         <p:nvSpPr>
-          <p:cNvPr id="11" name="Shape 9"/>
-          <p:cNvSpPr/>
-          <p:nvPr/>
-        </p:nvSpPr>
-        <p:spPr>
-          <a:xfrm>
-            <a:off x="6473952" y="2267712"/>
-            <a:ext cx="548640" cy="548640"/>
+          <p:cNvPr id="16" name="Shape 14"/>
+          <p:cNvSpPr/>
+          <p:nvPr/>
+        </p:nvSpPr>
+        <p:spPr>
+          <a:xfrm>
+            <a:off x="868680" y="3044952"/>
+            <a:ext cx="512064" cy="512064"/>
           </a:xfrm>
           <a:prstGeom prst="roundRect">
             <a:avLst>
@@ -4665,14 +4831,14 @@
       </p:sp>
       <p:sp>
         <p:nvSpPr>
-          <p:cNvPr id="12" name="Text 10"/>
-          <p:cNvSpPr/>
-          <p:nvPr/>
-        </p:nvSpPr>
-        <p:spPr>
-          <a:xfrm>
-            <a:off x="6473952" y="2267712"/>
-            <a:ext cx="548640" cy="548640"/>
+          <p:cNvPr id="17" name="Text 15"/>
+          <p:cNvSpPr/>
+          <p:nvPr/>
+        </p:nvSpPr>
+        <p:spPr>
+          <a:xfrm>
+            <a:off x="868680" y="3044952"/>
+            <a:ext cx="512064" cy="512064"/>
           </a:xfrm>
           <a:prstGeom prst="rect">
             <a:avLst/>
@@ -4688,7 +4854,7 @@
               <a:buNone/>
             </a:pPr>
             <a:r>
-              <a:rPr lang="en-US" sz="2000" b="1" dirty="0">
+              <a:rPr lang="en-US" sz="1800" b="1" dirty="0">
                 <a:solidFill>
                   <a:srgbClr val="0D2B45"/>
                 </a:solidFill>
@@ -4696,38 +4862,38 @@
                 <a:ea typeface="Georgia" pitchFamily="34" charset="-122"/>
                 <a:cs typeface="Georgia" pitchFamily="34" charset="-120"/>
               </a:rPr>
-              <a:t>2</a:t>
-            </a:r>
-            <a:endParaRPr lang="en-US" sz="2000" dirty="0"/>
-          </a:p>
-        </p:txBody>
-      </p:sp>
-      <p:sp>
-        <p:nvSpPr>
-          <p:cNvPr id="13" name="Text 11"/>
-          <p:cNvSpPr/>
-          <p:nvPr/>
-        </p:nvSpPr>
-        <p:spPr>
-          <a:xfrm>
-            <a:off x="7178040" y="2148840"/>
-            <a:ext cx="4114800" cy="411480"/>
-          </a:xfrm>
-          <a:prstGeom prst="rect">
-            <a:avLst/>
-          </a:prstGeom>
-          <a:noFill/>
-          <a:ln/>
-        </p:spPr>
-        <p:txBody>
-          <a:bodyPr wrap="square" rtlCol="0" anchor="ctr"/>
-          <a:lstStyle/>
-          <a:p>
-            <a:pPr indent="0" marL="0">
-              <a:buNone/>
-            </a:pPr>
-            <a:r>
-              <a:rPr lang="en-US" sz="1550" b="1" dirty="0">
+              <a:t>3</a:t>
+            </a:r>
+            <a:endParaRPr lang="en-US" sz="1800" dirty="0"/>
+          </a:p>
+        </p:txBody>
+      </p:sp>
+      <p:sp>
+        <p:nvSpPr>
+          <p:cNvPr id="18" name="Text 16"/>
+          <p:cNvSpPr/>
+          <p:nvPr/>
+        </p:nvSpPr>
+        <p:spPr>
+          <a:xfrm>
+            <a:off x="1536192" y="2926080"/>
+            <a:ext cx="4206240" cy="365760"/>
+          </a:xfrm>
+          <a:prstGeom prst="rect">
+            <a:avLst/>
+          </a:prstGeom>
+          <a:noFill/>
+          <a:ln/>
+        </p:spPr>
+        <p:txBody>
+          <a:bodyPr wrap="square" rtlCol="0" anchor="ctr"/>
+          <a:lstStyle/>
+          <a:p>
+            <a:pPr indent="0" marL="0">
+              <a:buNone/>
+            </a:pPr>
+            <a:r>
+              <a:rPr lang="en-US" sz="1500" b="1" dirty="0">
                 <a:solidFill>
                   <a:srgbClr val="FFFFFF"/>
                 </a:solidFill>
@@ -4737,36 +4903,36 @@
               </a:rPr>
               <a:t>Importación bancaria</a:t>
             </a:r>
-            <a:endParaRPr lang="en-US" sz="1550" dirty="0"/>
-          </a:p>
-        </p:txBody>
-      </p:sp>
-      <p:sp>
-        <p:nvSpPr>
-          <p:cNvPr id="14" name="Text 12"/>
-          <p:cNvSpPr/>
-          <p:nvPr/>
-        </p:nvSpPr>
-        <p:spPr>
-          <a:xfrm>
-            <a:off x="7178040" y="2560320"/>
-            <a:ext cx="4114800" cy="457200"/>
-          </a:xfrm>
-          <a:prstGeom prst="rect">
-            <a:avLst/>
-          </a:prstGeom>
-          <a:noFill/>
-          <a:ln/>
-        </p:spPr>
-        <p:txBody>
-          <a:bodyPr wrap="square" rtlCol="0" anchor="ctr"/>
-          <a:lstStyle/>
-          <a:p>
-            <a:pPr indent="0" marL="0">
-              <a:buNone/>
-            </a:pPr>
-            <a:r>
-              <a:rPr lang="en-US" sz="1150" dirty="0">
+            <a:endParaRPr lang="en-US" sz="1500" dirty="0"/>
+          </a:p>
+        </p:txBody>
+      </p:sp>
+      <p:sp>
+        <p:nvSpPr>
+          <p:cNvPr id="19" name="Text 17"/>
+          <p:cNvSpPr/>
+          <p:nvPr/>
+        </p:nvSpPr>
+        <p:spPr>
+          <a:xfrm>
+            <a:off x="1536192" y="3291840"/>
+            <a:ext cx="4206240" cy="384048"/>
+          </a:xfrm>
+          <a:prstGeom prst="rect">
+            <a:avLst/>
+          </a:prstGeom>
+          <a:noFill/>
+          <a:ln/>
+        </p:spPr>
+        <p:txBody>
+          <a:bodyPr wrap="square" rtlCol="0" anchor="ctr"/>
+          <a:lstStyle/>
+          <a:p>
+            <a:pPr indent="0" marL="0">
+              <a:buNone/>
+            </a:pPr>
+            <a:r>
+              <a:rPr lang="en-US" sz="1100" dirty="0">
                 <a:solidFill>
                   <a:srgbClr val="CADCFC"/>
                 </a:solidFill>
@@ -4776,24 +4942,24 @@
               </a:rPr>
               <a:t>Nueve formatos de homebanking, detección heurística local</a:t>
             </a:r>
-            <a:endParaRPr lang="en-US" sz="1150" dirty="0"/>
-          </a:p>
-        </p:txBody>
-      </p:sp>
-      <p:sp>
-        <p:nvSpPr>
-          <p:cNvPr id="15" name="Shape 13"/>
-          <p:cNvSpPr/>
-          <p:nvPr/>
-        </p:nvSpPr>
-        <p:spPr>
-          <a:xfrm>
-            <a:off x="640080" y="3337560"/>
-            <a:ext cx="5257800" cy="1143000"/>
+            <a:endParaRPr lang="en-US" sz="1100" dirty="0"/>
+          </a:p>
+        </p:txBody>
+      </p:sp>
+      <p:sp>
+        <p:nvSpPr>
+          <p:cNvPr id="20" name="Shape 18"/>
+          <p:cNvSpPr/>
+          <p:nvPr/>
+        </p:nvSpPr>
+        <p:spPr>
+          <a:xfrm>
+            <a:off x="6217920" y="2852928"/>
+            <a:ext cx="5257800" cy="896112"/>
           </a:xfrm>
           <a:prstGeom prst="roundRect">
             <a:avLst>
-              <a:gd name="adj" fmla="val 6400"/>
+              <a:gd name="adj" fmla="val 8163"/>
             </a:avLst>
           </a:prstGeom>
           <a:solidFill>
@@ -4809,14 +4975,14 @@
       </p:sp>
       <p:sp>
         <p:nvSpPr>
-          <p:cNvPr id="16" name="Shape 14"/>
-          <p:cNvSpPr/>
-          <p:nvPr/>
-        </p:nvSpPr>
-        <p:spPr>
-          <a:xfrm>
-            <a:off x="896112" y="3639312"/>
-            <a:ext cx="548640" cy="548640"/>
+          <p:cNvPr id="21" name="Shape 19"/>
+          <p:cNvSpPr/>
+          <p:nvPr/>
+        </p:nvSpPr>
+        <p:spPr>
+          <a:xfrm>
+            <a:off x="6446520" y="3044952"/>
+            <a:ext cx="512064" cy="512064"/>
           </a:xfrm>
           <a:prstGeom prst="roundRect">
             <a:avLst>
@@ -4831,14 +4997,14 @@
       </p:sp>
       <p:sp>
         <p:nvSpPr>
-          <p:cNvPr id="17" name="Text 15"/>
-          <p:cNvSpPr/>
-          <p:nvPr/>
-        </p:nvSpPr>
-        <p:spPr>
-          <a:xfrm>
-            <a:off x="896112" y="3639312"/>
-            <a:ext cx="548640" cy="548640"/>
+          <p:cNvPr id="22" name="Text 20"/>
+          <p:cNvSpPr/>
+          <p:nvPr/>
+        </p:nvSpPr>
+        <p:spPr>
+          <a:xfrm>
+            <a:off x="6446520" y="3044952"/>
+            <a:ext cx="512064" cy="512064"/>
           </a:xfrm>
           <a:prstGeom prst="rect">
             <a:avLst/>
@@ -4854,7 +5020,7 @@
               <a:buNone/>
             </a:pPr>
             <a:r>
-              <a:rPr lang="en-US" sz="2000" b="1" dirty="0">
+              <a:rPr lang="en-US" sz="1800" b="1" dirty="0">
                 <a:solidFill>
                   <a:srgbClr val="0D2B45"/>
                 </a:solidFill>
@@ -4862,38 +5028,38 @@
                 <a:ea typeface="Georgia" pitchFamily="34" charset="-122"/>
                 <a:cs typeface="Georgia" pitchFamily="34" charset="-120"/>
               </a:rPr>
-              <a:t>3</a:t>
-            </a:r>
-            <a:endParaRPr lang="en-US" sz="2000" dirty="0"/>
-          </a:p>
-        </p:txBody>
-      </p:sp>
-      <p:sp>
-        <p:nvSpPr>
-          <p:cNvPr id="18" name="Text 16"/>
-          <p:cNvSpPr/>
-          <p:nvPr/>
-        </p:nvSpPr>
-        <p:spPr>
-          <a:xfrm>
-            <a:off x="1600200" y="3520440"/>
-            <a:ext cx="4114800" cy="411480"/>
-          </a:xfrm>
-          <a:prstGeom prst="rect">
-            <a:avLst/>
-          </a:prstGeom>
-          <a:noFill/>
-          <a:ln/>
-        </p:spPr>
-        <p:txBody>
-          <a:bodyPr wrap="square" rtlCol="0" anchor="ctr"/>
-          <a:lstStyle/>
-          <a:p>
-            <a:pPr indent="0" marL="0">
-              <a:buNone/>
-            </a:pPr>
-            <a:r>
-              <a:rPr lang="en-US" sz="1550" b="1" dirty="0">
+              <a:t>4</a:t>
+            </a:r>
+            <a:endParaRPr lang="en-US" sz="1800" dirty="0"/>
+          </a:p>
+        </p:txBody>
+      </p:sp>
+      <p:sp>
+        <p:nvSpPr>
+          <p:cNvPr id="23" name="Text 21"/>
+          <p:cNvSpPr/>
+          <p:nvPr/>
+        </p:nvSpPr>
+        <p:spPr>
+          <a:xfrm>
+            <a:off x="7114032" y="2926080"/>
+            <a:ext cx="4206240" cy="365760"/>
+          </a:xfrm>
+          <a:prstGeom prst="rect">
+            <a:avLst/>
+          </a:prstGeom>
+          <a:noFill/>
+          <a:ln/>
+        </p:spPr>
+        <p:txBody>
+          <a:bodyPr wrap="square" rtlCol="0" anchor="ctr"/>
+          <a:lstStyle/>
+          <a:p>
+            <a:pPr indent="0" marL="0">
+              <a:buNone/>
+            </a:pPr>
+            <a:r>
+              <a:rPr lang="en-US" sz="1500" b="1" dirty="0">
                 <a:solidFill>
                   <a:srgbClr val="FFFFFF"/>
                 </a:solidFill>
@@ -4903,36 +5069,36 @@
               </a:rPr>
               <a:t>Auditoría automatizada</a:t>
             </a:r>
-            <a:endParaRPr lang="en-US" sz="1550" dirty="0"/>
-          </a:p>
-        </p:txBody>
-      </p:sp>
-      <p:sp>
-        <p:nvSpPr>
-          <p:cNvPr id="19" name="Text 17"/>
-          <p:cNvSpPr/>
-          <p:nvPr/>
-        </p:nvSpPr>
-        <p:spPr>
-          <a:xfrm>
-            <a:off x="1600200" y="3931920"/>
-            <a:ext cx="4114800" cy="457200"/>
-          </a:xfrm>
-          <a:prstGeom prst="rect">
-            <a:avLst/>
-          </a:prstGeom>
-          <a:noFill/>
-          <a:ln/>
-        </p:spPr>
-        <p:txBody>
-          <a:bodyPr wrap="square" rtlCol="0" anchor="ctr"/>
-          <a:lstStyle/>
-          <a:p>
-            <a:pPr indent="0" marL="0">
-              <a:buNone/>
-            </a:pPr>
-            <a:r>
-              <a:rPr lang="en-US" sz="1150" dirty="0">
+            <a:endParaRPr lang="en-US" sz="1500" dirty="0"/>
+          </a:p>
+        </p:txBody>
+      </p:sp>
+      <p:sp>
+        <p:nvSpPr>
+          <p:cNvPr id="24" name="Text 22"/>
+          <p:cNvSpPr/>
+          <p:nvPr/>
+        </p:nvSpPr>
+        <p:spPr>
+          <a:xfrm>
+            <a:off x="7114032" y="3291840"/>
+            <a:ext cx="4206240" cy="384048"/>
+          </a:xfrm>
+          <a:prstGeom prst="rect">
+            <a:avLst/>
+          </a:prstGeom>
+          <a:noFill/>
+          <a:ln/>
+        </p:spPr>
+        <p:txBody>
+          <a:bodyPr wrap="square" rtlCol="0" anchor="ctr"/>
+          <a:lstStyle/>
+          <a:p>
+            <a:pPr indent="0" marL="0">
+              <a:buNone/>
+            </a:pPr>
+            <a:r>
+              <a:rPr lang="en-US" sz="1100" dirty="0">
                 <a:solidFill>
                   <a:srgbClr val="CADCFC"/>
                 </a:solidFill>
@@ -4942,24 +5108,24 @@
               </a:rPr>
               <a:t>Cinco detectores sobre los registros del usuario</a:t>
             </a:r>
-            <a:endParaRPr lang="en-US" sz="1150" dirty="0"/>
-          </a:p>
-        </p:txBody>
-      </p:sp>
-      <p:sp>
-        <p:nvSpPr>
-          <p:cNvPr id="20" name="Shape 18"/>
-          <p:cNvSpPr/>
-          <p:nvPr/>
-        </p:nvSpPr>
-        <p:spPr>
-          <a:xfrm>
-            <a:off x="6217920" y="3337560"/>
-            <a:ext cx="5257800" cy="1143000"/>
+            <a:endParaRPr lang="en-US" sz="1100" dirty="0"/>
+          </a:p>
+        </p:txBody>
+      </p:sp>
+      <p:sp>
+        <p:nvSpPr>
+          <p:cNvPr id="25" name="Shape 23"/>
+          <p:cNvSpPr/>
+          <p:nvPr/>
+        </p:nvSpPr>
+        <p:spPr>
+          <a:xfrm>
+            <a:off x="640080" y="3877056"/>
+            <a:ext cx="5257800" cy="896112"/>
           </a:xfrm>
           <a:prstGeom prst="roundRect">
             <a:avLst>
-              <a:gd name="adj" fmla="val 6400"/>
+              <a:gd name="adj" fmla="val 8163"/>
             </a:avLst>
           </a:prstGeom>
           <a:solidFill>
@@ -4975,14 +5141,14 @@
       </p:sp>
       <p:sp>
         <p:nvSpPr>
-          <p:cNvPr id="21" name="Shape 19"/>
-          <p:cNvSpPr/>
-          <p:nvPr/>
-        </p:nvSpPr>
-        <p:spPr>
-          <a:xfrm>
-            <a:off x="6473952" y="3639312"/>
-            <a:ext cx="548640" cy="548640"/>
+          <p:cNvPr id="26" name="Shape 24"/>
+          <p:cNvSpPr/>
+          <p:nvPr/>
+        </p:nvSpPr>
+        <p:spPr>
+          <a:xfrm>
+            <a:off x="868680" y="4069080"/>
+            <a:ext cx="512064" cy="512064"/>
           </a:xfrm>
           <a:prstGeom prst="roundRect">
             <a:avLst>
@@ -4997,14 +5163,14 @@
       </p:sp>
       <p:sp>
         <p:nvSpPr>
-          <p:cNvPr id="22" name="Text 20"/>
-          <p:cNvSpPr/>
-          <p:nvPr/>
-        </p:nvSpPr>
-        <p:spPr>
-          <a:xfrm>
-            <a:off x="6473952" y="3639312"/>
-            <a:ext cx="548640" cy="548640"/>
+          <p:cNvPr id="27" name="Text 25"/>
+          <p:cNvSpPr/>
+          <p:nvPr/>
+        </p:nvSpPr>
+        <p:spPr>
+          <a:xfrm>
+            <a:off x="868680" y="4069080"/>
+            <a:ext cx="512064" cy="512064"/>
           </a:xfrm>
           <a:prstGeom prst="rect">
             <a:avLst/>
@@ -5020,7 +5186,7 @@
               <a:buNone/>
             </a:pPr>
             <a:r>
-              <a:rPr lang="en-US" sz="2000" b="1" dirty="0">
+              <a:rPr lang="en-US" sz="1800" b="1" dirty="0">
                 <a:solidFill>
                   <a:srgbClr val="0D2B45"/>
                 </a:solidFill>
@@ -5028,38 +5194,38 @@
                 <a:ea typeface="Georgia" pitchFamily="34" charset="-122"/>
                 <a:cs typeface="Georgia" pitchFamily="34" charset="-120"/>
               </a:rPr>
-              <a:t>4</a:t>
-            </a:r>
-            <a:endParaRPr lang="en-US" sz="2000" dirty="0"/>
-          </a:p>
-        </p:txBody>
-      </p:sp>
-      <p:sp>
-        <p:nvSpPr>
-          <p:cNvPr id="23" name="Text 21"/>
-          <p:cNvSpPr/>
-          <p:nvPr/>
-        </p:nvSpPr>
-        <p:spPr>
-          <a:xfrm>
-            <a:off x="7178040" y="3520440"/>
-            <a:ext cx="4114800" cy="411480"/>
-          </a:xfrm>
-          <a:prstGeom prst="rect">
-            <a:avLst/>
-          </a:prstGeom>
-          <a:noFill/>
-          <a:ln/>
-        </p:spPr>
-        <p:txBody>
-          <a:bodyPr wrap="square" rtlCol="0" anchor="ctr"/>
-          <a:lstStyle/>
-          <a:p>
-            <a:pPr indent="0" marL="0">
-              <a:buNone/>
-            </a:pPr>
-            <a:r>
-              <a:rPr lang="en-US" sz="1550" b="1" dirty="0">
+              <a:t>5</a:t>
+            </a:r>
+            <a:endParaRPr lang="en-US" sz="1800" dirty="0"/>
+          </a:p>
+        </p:txBody>
+      </p:sp>
+      <p:sp>
+        <p:nvSpPr>
+          <p:cNvPr id="28" name="Text 26"/>
+          <p:cNvSpPr/>
+          <p:nvPr/>
+        </p:nvSpPr>
+        <p:spPr>
+          <a:xfrm>
+            <a:off x="1536192" y="3950208"/>
+            <a:ext cx="4206240" cy="365760"/>
+          </a:xfrm>
+          <a:prstGeom prst="rect">
+            <a:avLst/>
+          </a:prstGeom>
+          <a:noFill/>
+          <a:ln/>
+        </p:spPr>
+        <p:txBody>
+          <a:bodyPr wrap="square" rtlCol="0" anchor="ctr"/>
+          <a:lstStyle/>
+          <a:p>
+            <a:pPr indent="0" marL="0">
+              <a:buNone/>
+            </a:pPr>
+            <a:r>
+              <a:rPr lang="en-US" sz="1500" b="1" dirty="0">
                 <a:solidFill>
                   <a:srgbClr val="FFFFFF"/>
                 </a:solidFill>
@@ -5069,36 +5235,36 @@
               </a:rPr>
               <a:t>Estado fiscal</a:t>
             </a:r>
-            <a:endParaRPr lang="en-US" sz="1550" dirty="0"/>
-          </a:p>
-        </p:txBody>
-      </p:sp>
-      <p:sp>
-        <p:nvSpPr>
-          <p:cNvPr id="24" name="Text 22"/>
-          <p:cNvSpPr/>
-          <p:nvPr/>
-        </p:nvSpPr>
-        <p:spPr>
-          <a:xfrm>
-            <a:off x="7178040" y="3931920"/>
-            <a:ext cx="4114800" cy="457200"/>
-          </a:xfrm>
-          <a:prstGeom prst="rect">
-            <a:avLst/>
-          </a:prstGeom>
-          <a:noFill/>
-          <a:ln/>
-        </p:spPr>
-        <p:txBody>
-          <a:bodyPr wrap="square" rtlCol="0" anchor="ctr"/>
-          <a:lstStyle/>
-          <a:p>
-            <a:pPr indent="0" marL="0">
-              <a:buNone/>
-            </a:pPr>
-            <a:r>
-              <a:rPr lang="en-US" sz="1150" dirty="0">
+            <a:endParaRPr lang="en-US" sz="1500" dirty="0"/>
+          </a:p>
+        </p:txBody>
+      </p:sp>
+      <p:sp>
+        <p:nvSpPr>
+          <p:cNvPr id="29" name="Text 27"/>
+          <p:cNvSpPr/>
+          <p:nvPr/>
+        </p:nvSpPr>
+        <p:spPr>
+          <a:xfrm>
+            <a:off x="1536192" y="4315968"/>
+            <a:ext cx="4206240" cy="384048"/>
+          </a:xfrm>
+          <a:prstGeom prst="rect">
+            <a:avLst/>
+          </a:prstGeom>
+          <a:noFill/>
+          <a:ln/>
+        </p:spPr>
+        <p:txBody>
+          <a:bodyPr wrap="square" rtlCol="0" anchor="ctr"/>
+          <a:lstStyle/>
+          <a:p>
+            <a:pPr indent="0" marL="0">
+              <a:buNone/>
+            </a:pPr>
+            <a:r>
+              <a:rPr lang="en-US" sz="1100" dirty="0">
                 <a:solidFill>
                   <a:srgbClr val="CADCFC"/>
                 </a:solidFill>
@@ -5108,24 +5274,190 @@
               </a:rPr>
               <a:t>Año en curso + proyección hasta diciembre contra el límite de la categoría</a:t>
             </a:r>
-            <a:endParaRPr lang="en-US" sz="1150" dirty="0"/>
-          </a:p>
-        </p:txBody>
-      </p:sp>
-      <p:sp>
-        <p:nvSpPr>
-          <p:cNvPr id="25" name="Shape 23"/>
-          <p:cNvSpPr/>
-          <p:nvPr/>
-        </p:nvSpPr>
-        <p:spPr>
-          <a:xfrm>
-            <a:off x="640080" y="4709160"/>
-            <a:ext cx="5257800" cy="1143000"/>
+            <a:endParaRPr lang="en-US" sz="1100" dirty="0"/>
+          </a:p>
+        </p:txBody>
+      </p:sp>
+      <p:sp>
+        <p:nvSpPr>
+          <p:cNvPr id="30" name="Shape 28"/>
+          <p:cNvSpPr/>
+          <p:nvPr/>
+        </p:nvSpPr>
+        <p:spPr>
+          <a:xfrm>
+            <a:off x="6217920" y="3877056"/>
+            <a:ext cx="5257800" cy="896112"/>
           </a:xfrm>
           <a:prstGeom prst="roundRect">
             <a:avLst>
-              <a:gd name="adj" fmla="val 6400"/>
+              <a:gd name="adj" fmla="val 8163"/>
+            </a:avLst>
+          </a:prstGeom>
+          <a:solidFill>
+            <a:srgbClr val="14395E"/>
+          </a:solidFill>
+          <a:ln w="12700">
+            <a:solidFill>
+              <a:srgbClr val="E0A82E"/>
+            </a:solidFill>
+            <a:prstDash val="solid"/>
+          </a:ln>
+        </p:spPr>
+      </p:sp>
+      <p:sp>
+        <p:nvSpPr>
+          <p:cNvPr id="31" name="Shape 29"/>
+          <p:cNvSpPr/>
+          <p:nvPr/>
+        </p:nvSpPr>
+        <p:spPr>
+          <a:xfrm>
+            <a:off x="6446520" y="4069080"/>
+            <a:ext cx="512064" cy="512064"/>
+          </a:xfrm>
+          <a:prstGeom prst="roundRect">
+            <a:avLst>
+              <a:gd name="adj" fmla="val 50000"/>
+            </a:avLst>
+          </a:prstGeom>
+          <a:solidFill>
+            <a:srgbClr val="E0A82E"/>
+          </a:solidFill>
+          <a:ln/>
+        </p:spPr>
+      </p:sp>
+      <p:sp>
+        <p:nvSpPr>
+          <p:cNvPr id="32" name="Text 30"/>
+          <p:cNvSpPr/>
+          <p:nvPr/>
+        </p:nvSpPr>
+        <p:spPr>
+          <a:xfrm>
+            <a:off x="6446520" y="4069080"/>
+            <a:ext cx="512064" cy="512064"/>
+          </a:xfrm>
+          <a:prstGeom prst="rect">
+            <a:avLst/>
+          </a:prstGeom>
+          <a:noFill/>
+          <a:ln/>
+        </p:spPr>
+        <p:txBody>
+          <a:bodyPr wrap="square" rtlCol="0" anchor="ctr"/>
+          <a:lstStyle/>
+          <a:p>
+            <a:pPr algn="ctr" indent="0" marL="0">
+              <a:buNone/>
+            </a:pPr>
+            <a:r>
+              <a:rPr lang="en-US" sz="1800" b="1" dirty="0">
+                <a:solidFill>
+                  <a:srgbClr val="0D2B45"/>
+                </a:solidFill>
+                <a:latin typeface="Georgia" pitchFamily="34" charset="0"/>
+                <a:ea typeface="Georgia" pitchFamily="34" charset="-122"/>
+                <a:cs typeface="Georgia" pitchFamily="34" charset="-120"/>
+              </a:rPr>
+              <a:t>6</a:t>
+            </a:r>
+            <a:endParaRPr lang="en-US" sz="1800" dirty="0"/>
+          </a:p>
+        </p:txBody>
+      </p:sp>
+      <p:sp>
+        <p:nvSpPr>
+          <p:cNvPr id="33" name="Text 31"/>
+          <p:cNvSpPr/>
+          <p:nvPr/>
+        </p:nvSpPr>
+        <p:spPr>
+          <a:xfrm>
+            <a:off x="7114032" y="3950208"/>
+            <a:ext cx="4206240" cy="365760"/>
+          </a:xfrm>
+          <a:prstGeom prst="rect">
+            <a:avLst/>
+          </a:prstGeom>
+          <a:noFill/>
+          <a:ln/>
+        </p:spPr>
+        <p:txBody>
+          <a:bodyPr wrap="square" rtlCol="0" anchor="ctr"/>
+          <a:lstStyle/>
+          <a:p>
+            <a:pPr indent="0" marL="0">
+              <a:buNone/>
+            </a:pPr>
+            <a:r>
+              <a:rPr lang="en-US" sz="1500" b="1" dirty="0">
+                <a:solidFill>
+                  <a:srgbClr val="FFFFFF"/>
+                </a:solidFill>
+                <a:latin typeface="Georgia" pitchFamily="34" charset="0"/>
+                <a:ea typeface="Georgia" pitchFamily="34" charset="-122"/>
+                <a:cs typeface="Georgia" pitchFamily="34" charset="-120"/>
+              </a:rPr>
+              <a:t>Proyección de ingresos</a:t>
+            </a:r>
+            <a:endParaRPr lang="en-US" sz="1500" dirty="0"/>
+          </a:p>
+        </p:txBody>
+      </p:sp>
+      <p:sp>
+        <p:nvSpPr>
+          <p:cNvPr id="34" name="Text 32"/>
+          <p:cNvSpPr/>
+          <p:nvPr/>
+        </p:nvSpPr>
+        <p:spPr>
+          <a:xfrm>
+            <a:off x="7114032" y="4315968"/>
+            <a:ext cx="4206240" cy="384048"/>
+          </a:xfrm>
+          <a:prstGeom prst="rect">
+            <a:avLst/>
+          </a:prstGeom>
+          <a:noFill/>
+          <a:ln/>
+        </p:spPr>
+        <p:txBody>
+          <a:bodyPr wrap="square" rtlCol="0" anchor="ctr"/>
+          <a:lstStyle/>
+          <a:p>
+            <a:pPr indent="0" marL="0">
+              <a:buNone/>
+            </a:pPr>
+            <a:r>
+              <a:rPr lang="en-US" sz="1100" dirty="0">
+                <a:solidFill>
+                  <a:srgbClr val="CADCFC"/>
+                </a:solidFill>
+                <a:latin typeface="Calibri" pitchFamily="34" charset="0"/>
+                <a:ea typeface="Calibri" pitchFamily="34" charset="-122"/>
+                <a:cs typeface="Calibri" pitchFamily="34" charset="-120"/>
+              </a:rPr>
+              <a:t>Seis meses con intervalo de confianza y arranque en frío</a:t>
+            </a:r>
+            <a:endParaRPr lang="en-US" sz="1100" dirty="0"/>
+          </a:p>
+        </p:txBody>
+      </p:sp>
+      <p:sp>
+        <p:nvSpPr>
+          <p:cNvPr id="35" name="Shape 33"/>
+          <p:cNvSpPr/>
+          <p:nvPr/>
+        </p:nvSpPr>
+        <p:spPr>
+          <a:xfrm>
+            <a:off x="640080" y="4901184"/>
+            <a:ext cx="5257800" cy="896112"/>
+          </a:xfrm>
+          <a:prstGeom prst="roundRect">
+            <a:avLst>
+              <a:gd name="adj" fmla="val 8163"/>
             </a:avLst>
           </a:prstGeom>
           <a:solidFill>
@@ -5141,14 +5473,14 @@
       </p:sp>
       <p:sp>
         <p:nvSpPr>
-          <p:cNvPr id="26" name="Shape 24"/>
-          <p:cNvSpPr/>
-          <p:nvPr/>
-        </p:nvSpPr>
-        <p:spPr>
-          <a:xfrm>
-            <a:off x="896112" y="5010912"/>
-            <a:ext cx="548640" cy="548640"/>
+          <p:cNvPr id="36" name="Shape 34"/>
+          <p:cNvSpPr/>
+          <p:nvPr/>
+        </p:nvSpPr>
+        <p:spPr>
+          <a:xfrm>
+            <a:off x="868680" y="5093208"/>
+            <a:ext cx="512064" cy="512064"/>
           </a:xfrm>
           <a:prstGeom prst="roundRect">
             <a:avLst>
@@ -5163,14 +5495,14 @@
       </p:sp>
       <p:sp>
         <p:nvSpPr>
-          <p:cNvPr id="27" name="Text 25"/>
-          <p:cNvSpPr/>
-          <p:nvPr/>
-        </p:nvSpPr>
-        <p:spPr>
-          <a:xfrm>
-            <a:off x="896112" y="5010912"/>
-            <a:ext cx="548640" cy="548640"/>
+          <p:cNvPr id="37" name="Text 35"/>
+          <p:cNvSpPr/>
+          <p:nvPr/>
+        </p:nvSpPr>
+        <p:spPr>
+          <a:xfrm>
+            <a:off x="868680" y="5093208"/>
+            <a:ext cx="512064" cy="512064"/>
           </a:xfrm>
           <a:prstGeom prst="rect">
             <a:avLst/>
@@ -5186,7 +5518,7 @@
               <a:buNone/>
             </a:pPr>
             <a:r>
-              <a:rPr lang="en-US" sz="2000" b="1" dirty="0">
+              <a:rPr lang="en-US" sz="1800" b="1" dirty="0">
                 <a:solidFill>
                   <a:srgbClr val="0D2B45"/>
                 </a:solidFill>
@@ -5194,38 +5526,38 @@
                 <a:ea typeface="Georgia" pitchFamily="34" charset="-122"/>
                 <a:cs typeface="Georgia" pitchFamily="34" charset="-120"/>
               </a:rPr>
-              <a:t>5</a:t>
-            </a:r>
-            <a:endParaRPr lang="en-US" sz="2000" dirty="0"/>
-          </a:p>
-        </p:txBody>
-      </p:sp>
-      <p:sp>
-        <p:nvSpPr>
-          <p:cNvPr id="28" name="Text 26"/>
-          <p:cNvSpPr/>
-          <p:nvPr/>
-        </p:nvSpPr>
-        <p:spPr>
-          <a:xfrm>
-            <a:off x="1600200" y="4892040"/>
-            <a:ext cx="4114800" cy="411480"/>
-          </a:xfrm>
-          <a:prstGeom prst="rect">
-            <a:avLst/>
-          </a:prstGeom>
-          <a:noFill/>
-          <a:ln/>
-        </p:spPr>
-        <p:txBody>
-          <a:bodyPr wrap="square" rtlCol="0" anchor="ctr"/>
-          <a:lstStyle/>
-          <a:p>
-            <a:pPr indent="0" marL="0">
-              <a:buNone/>
-            </a:pPr>
-            <a:r>
-              <a:rPr lang="en-US" sz="1550" b="1" dirty="0">
+              <a:t>7</a:t>
+            </a:r>
+            <a:endParaRPr lang="en-US" sz="1800" dirty="0"/>
+          </a:p>
+        </p:txBody>
+      </p:sp>
+      <p:sp>
+        <p:nvSpPr>
+          <p:cNvPr id="38" name="Text 36"/>
+          <p:cNvSpPr/>
+          <p:nvPr/>
+        </p:nvSpPr>
+        <p:spPr>
+          <a:xfrm>
+            <a:off x="1536192" y="4974336"/>
+            <a:ext cx="4206240" cy="365760"/>
+          </a:xfrm>
+          <a:prstGeom prst="rect">
+            <a:avLst/>
+          </a:prstGeom>
+          <a:noFill/>
+          <a:ln/>
+        </p:spPr>
+        <p:txBody>
+          <a:bodyPr wrap="square" rtlCol="0" anchor="ctr"/>
+          <a:lstStyle/>
+          <a:p>
+            <a:pPr indent="0" marL="0">
+              <a:buNone/>
+            </a:pPr>
+            <a:r>
+              <a:rPr lang="en-US" sz="1500" b="1" dirty="0">
                 <a:solidFill>
                   <a:srgbClr val="FFFFFF"/>
                 </a:solidFill>
@@ -5233,38 +5565,38 @@
                 <a:ea typeface="Georgia" pitchFamily="34" charset="-122"/>
                 <a:cs typeface="Georgia" pitchFamily="34" charset="-120"/>
               </a:rPr>
-              <a:t>Proyección de ingresos</a:t>
-            </a:r>
-            <a:endParaRPr lang="en-US" sz="1550" dirty="0"/>
-          </a:p>
-        </p:txBody>
-      </p:sp>
-      <p:sp>
-        <p:nvSpPr>
-          <p:cNvPr id="29" name="Text 27"/>
-          <p:cNvSpPr/>
-          <p:nvPr/>
-        </p:nvSpPr>
-        <p:spPr>
-          <a:xfrm>
-            <a:off x="1600200" y="5303520"/>
-            <a:ext cx="4114800" cy="457200"/>
-          </a:xfrm>
-          <a:prstGeom prst="rect">
-            <a:avLst/>
-          </a:prstGeom>
-          <a:noFill/>
-          <a:ln/>
-        </p:spPr>
-        <p:txBody>
-          <a:bodyPr wrap="square" rtlCol="0" anchor="ctr"/>
-          <a:lstStyle/>
-          <a:p>
-            <a:pPr indent="0" marL="0">
-              <a:buNone/>
-            </a:pPr>
-            <a:r>
-              <a:rPr lang="en-US" sz="1150" dirty="0">
+              <a:t>Resumen y recomendaciones</a:t>
+            </a:r>
+            <a:endParaRPr lang="en-US" sz="1500" dirty="0"/>
+          </a:p>
+        </p:txBody>
+      </p:sp>
+      <p:sp>
+        <p:nvSpPr>
+          <p:cNvPr id="39" name="Text 37"/>
+          <p:cNvSpPr/>
+          <p:nvPr/>
+        </p:nvSpPr>
+        <p:spPr>
+          <a:xfrm>
+            <a:off x="1536192" y="5340096"/>
+            <a:ext cx="4206240" cy="384048"/>
+          </a:xfrm>
+          <a:prstGeom prst="rect">
+            <a:avLst/>
+          </a:prstGeom>
+          <a:noFill/>
+          <a:ln/>
+        </p:spPr>
+        <p:txBody>
+          <a:bodyPr wrap="square" rtlCol="0" anchor="ctr"/>
+          <a:lstStyle/>
+          <a:p>
+            <a:pPr indent="0" marL="0">
+              <a:buNone/>
+            </a:pPr>
+            <a:r>
+              <a:rPr lang="en-US" sz="1100" dirty="0">
                 <a:solidFill>
                   <a:srgbClr val="CADCFC"/>
                 </a:solidFill>
@@ -5272,26 +5604,26 @@
                 <a:ea typeface="Calibri" pitchFamily="34" charset="-122"/>
                 <a:cs typeface="Calibri" pitchFamily="34" charset="-120"/>
               </a:rPr>
-              <a:t>Seis meses con intervalo de confianza y arranque en frío</a:t>
-            </a:r>
-            <a:endParaRPr lang="en-US" sz="1150" dirty="0"/>
-          </a:p>
-        </p:txBody>
-      </p:sp>
-      <p:sp>
-        <p:nvSpPr>
-          <p:cNvPr id="30" name="Shape 28"/>
-          <p:cNvSpPr/>
-          <p:nvPr/>
-        </p:nvSpPr>
-        <p:spPr>
-          <a:xfrm>
-            <a:off x="6217920" y="4709160"/>
-            <a:ext cx="5257800" cy="1143000"/>
+              <a:t>El mes en palabras (único uso de IA externa) y reglas fijas que sugieren</a:t>
+            </a:r>
+            <a:endParaRPr lang="en-US" sz="1100" dirty="0"/>
+          </a:p>
+        </p:txBody>
+      </p:sp>
+      <p:sp>
+        <p:nvSpPr>
+          <p:cNvPr id="40" name="Shape 38"/>
+          <p:cNvSpPr/>
+          <p:nvPr/>
+        </p:nvSpPr>
+        <p:spPr>
+          <a:xfrm>
+            <a:off x="6217920" y="4901184"/>
+            <a:ext cx="5257800" cy="896112"/>
           </a:xfrm>
           <a:prstGeom prst="roundRect">
             <a:avLst>
-              <a:gd name="adj" fmla="val 6400"/>
+              <a:gd name="adj" fmla="val 8163"/>
             </a:avLst>
           </a:prstGeom>
           <a:solidFill>
@@ -5307,14 +5639,14 @@
       </p:sp>
       <p:sp>
         <p:nvSpPr>
-          <p:cNvPr id="31" name="Shape 29"/>
-          <p:cNvSpPr/>
-          <p:nvPr/>
-        </p:nvSpPr>
-        <p:spPr>
-          <a:xfrm>
-            <a:off x="6473952" y="5010912"/>
-            <a:ext cx="548640" cy="548640"/>
+          <p:cNvPr id="41" name="Shape 39"/>
+          <p:cNvSpPr/>
+          <p:nvPr/>
+        </p:nvSpPr>
+        <p:spPr>
+          <a:xfrm>
+            <a:off x="6446520" y="5093208"/>
+            <a:ext cx="512064" cy="512064"/>
           </a:xfrm>
           <a:prstGeom prst="roundRect">
             <a:avLst>
@@ -5329,14 +5661,14 @@
       </p:sp>
       <p:sp>
         <p:nvSpPr>
-          <p:cNvPr id="32" name="Text 30"/>
-          <p:cNvSpPr/>
-          <p:nvPr/>
-        </p:nvSpPr>
-        <p:spPr>
-          <a:xfrm>
-            <a:off x="6473952" y="5010912"/>
-            <a:ext cx="548640" cy="548640"/>
+          <p:cNvPr id="42" name="Text 40"/>
+          <p:cNvSpPr/>
+          <p:nvPr/>
+        </p:nvSpPr>
+        <p:spPr>
+          <a:xfrm>
+            <a:off x="6446520" y="5093208"/>
+            <a:ext cx="512064" cy="512064"/>
           </a:xfrm>
           <a:prstGeom prst="rect">
             <a:avLst/>
@@ -5352,7 +5684,7 @@
               <a:buNone/>
             </a:pPr>
             <a:r>
-              <a:rPr lang="en-US" sz="2000" b="1" dirty="0">
+              <a:rPr lang="en-US" sz="1800" b="1" dirty="0">
                 <a:solidFill>
                   <a:srgbClr val="0D2B45"/>
                 </a:solidFill>
@@ -5360,38 +5692,38 @@
                 <a:ea typeface="Georgia" pitchFamily="34" charset="-122"/>
                 <a:cs typeface="Georgia" pitchFamily="34" charset="-120"/>
               </a:rPr>
-              <a:t>6</a:t>
-            </a:r>
-            <a:endParaRPr lang="en-US" sz="2000" dirty="0"/>
-          </a:p>
-        </p:txBody>
-      </p:sp>
-      <p:sp>
-        <p:nvSpPr>
-          <p:cNvPr id="33" name="Text 31"/>
-          <p:cNvSpPr/>
-          <p:nvPr/>
-        </p:nvSpPr>
-        <p:spPr>
-          <a:xfrm>
-            <a:off x="7178040" y="4892040"/>
-            <a:ext cx="4114800" cy="411480"/>
-          </a:xfrm>
-          <a:prstGeom prst="rect">
-            <a:avLst/>
-          </a:prstGeom>
-          <a:noFill/>
-          <a:ln/>
-        </p:spPr>
-        <p:txBody>
-          <a:bodyPr wrap="square" rtlCol="0" anchor="ctr"/>
-          <a:lstStyle/>
-          <a:p>
-            <a:pPr indent="0" marL="0">
-              <a:buNone/>
-            </a:pPr>
-            <a:r>
-              <a:rPr lang="en-US" sz="1550" b="1" dirty="0">
+              <a:t>8</a:t>
+            </a:r>
+            <a:endParaRPr lang="en-US" sz="1800" dirty="0"/>
+          </a:p>
+        </p:txBody>
+      </p:sp>
+      <p:sp>
+        <p:nvSpPr>
+          <p:cNvPr id="43" name="Text 41"/>
+          <p:cNvSpPr/>
+          <p:nvPr/>
+        </p:nvSpPr>
+        <p:spPr>
+          <a:xfrm>
+            <a:off x="7114032" y="4974336"/>
+            <a:ext cx="4206240" cy="365760"/>
+          </a:xfrm>
+          <a:prstGeom prst="rect">
+            <a:avLst/>
+          </a:prstGeom>
+          <a:noFill/>
+          <a:ln/>
+        </p:spPr>
+        <p:txBody>
+          <a:bodyPr wrap="square" rtlCol="0" anchor="ctr"/>
+          <a:lstStyle/>
+          <a:p>
+            <a:pPr indent="0" marL="0">
+              <a:buNone/>
+            </a:pPr>
+            <a:r>
+              <a:rPr lang="en-US" sz="1500" b="1" dirty="0">
                 <a:solidFill>
                   <a:srgbClr val="FFFFFF"/>
                 </a:solidFill>
@@ -5401,36 +5733,36 @@
               </a:rPr>
               <a:t>Reporte PDF</a:t>
             </a:r>
-            <a:endParaRPr lang="en-US" sz="1550" dirty="0"/>
-          </a:p>
-        </p:txBody>
-      </p:sp>
-      <p:sp>
-        <p:nvSpPr>
-          <p:cNvPr id="34" name="Text 32"/>
-          <p:cNvSpPr/>
-          <p:nvPr/>
-        </p:nvSpPr>
-        <p:spPr>
-          <a:xfrm>
-            <a:off x="7178040" y="5303520"/>
-            <a:ext cx="4114800" cy="457200"/>
-          </a:xfrm>
-          <a:prstGeom prst="rect">
-            <a:avLst/>
-          </a:prstGeom>
-          <a:noFill/>
-          <a:ln/>
-        </p:spPr>
-        <p:txBody>
-          <a:bodyPr wrap="square" rtlCol="0" anchor="ctr"/>
-          <a:lstStyle/>
-          <a:p>
-            <a:pPr indent="0" marL="0">
-              <a:buNone/>
-            </a:pPr>
-            <a:r>
-              <a:rPr lang="en-US" sz="1150" dirty="0">
+            <a:endParaRPr lang="en-US" sz="1500" dirty="0"/>
+          </a:p>
+        </p:txBody>
+      </p:sp>
+      <p:sp>
+        <p:nvSpPr>
+          <p:cNvPr id="44" name="Text 42"/>
+          <p:cNvSpPr/>
+          <p:nvPr/>
+        </p:nvSpPr>
+        <p:spPr>
+          <a:xfrm>
+            <a:off x="7114032" y="5340096"/>
+            <a:ext cx="4206240" cy="384048"/>
+          </a:xfrm>
+          <a:prstGeom prst="rect">
+            <a:avLst/>
+          </a:prstGeom>
+          <a:noFill/>
+          <a:ln/>
+        </p:spPr>
+        <p:txBody>
+          <a:bodyPr wrap="square" rtlCol="0" anchor="ctr"/>
+          <a:lstStyle/>
+          <a:p>
+            <a:pPr indent="0" marL="0">
+              <a:buNone/>
+            </a:pPr>
+            <a:r>
+              <a:rPr lang="en-US" sz="1100" dirty="0">
                 <a:solidFill>
                   <a:srgbClr val="CADCFC"/>
                 </a:solidFill>
@@ -5440,13 +5772,13 @@
               </a:rPr>
               <a:t>Documento mensual consolidado para el contador</a:t>
             </a:r>
-            <a:endParaRPr lang="en-US" sz="1150" dirty="0"/>
-          </a:p>
-        </p:txBody>
-      </p:sp>
-      <p:sp>
-        <p:nvSpPr>
-          <p:cNvPr id="35" name="Text 33"/>
+            <a:endParaRPr lang="en-US" sz="1100" dirty="0"/>
+          </a:p>
+        </p:txBody>
+      </p:sp>
+      <p:sp>
+        <p:nvSpPr>
+          <p:cNvPr id="45" name="Text 43"/>
           <p:cNvSpPr/>
           <p:nvPr/>
         </p:nvSpPr>
@@ -5485,7 +5817,7 @@
       </p:sp>
       <p:sp>
         <p:nvSpPr>
-          <p:cNvPr id="36" name="Text 34"/>
+          <p:cNvPr id="46" name="Text 44"/>
           <p:cNvSpPr/>
           <p:nvPr/>
         </p:nvSpPr>
@@ -5524,7 +5856,7 @@
       </p:sp>
       <p:sp>
         <p:nvSpPr>
-          <p:cNvPr id="37" name="Text 35"/>
+          <p:cNvPr id="47" name="Text 45"/>
           <p:cNvSpPr/>
           <p:nvPr/>
         </p:nvSpPr>
@@ -6553,7 +6885,7 @@
                 <a:ea typeface="Calibri" pitchFamily="34" charset="-122"/>
                 <a:cs typeface="Calibri" pitchFamily="34" charset="-120"/>
               </a:rPr>
-              <a:t>FastAPI 0.111 · Python 3.11 · ASGI · JWT · Pydantic</a:t>
+              <a:t>FastAPI 0.110 · Python 3.11 · ASGI · JWT · Pydantic</a:t>
             </a:r>
             <a:endParaRPr lang="en-US" sz="1250" dirty="0"/>
           </a:p>
@@ -7338,7 +7670,7 @@
                 <a:ea typeface="Calibri" pitchFamily="34" charset="-122"/>
                 <a:cs typeface="Calibri" pitchFamily="34" charset="-120"/>
               </a:rPr>
-              <a:t>pytest — 390 pruebas</a:t>
+              <a:t>pytest — 446 pruebas</a:t>
             </a:r>
             <a:endParaRPr lang="en-US" sz="1150" dirty="0"/>
           </a:p>
@@ -7565,7 +7897,7 @@
                 <a:ea typeface="Calibri" pitchFamily="34" charset="-122"/>
                 <a:cs typeface="Calibri" pitchFamily="34" charset="-120"/>
               </a:rPr>
-              <a:t>Bloque 5 · 25:00</a:t>
+              <a:t>Bloque 5 · 24:30</a:t>
             </a:r>
             <a:endParaRPr lang="en-US" sz="1050" dirty="0"/>
           </a:p>
@@ -7882,7 +8214,7 @@
                 <a:ea typeface="Calibri" pitchFamily="34" charset="-122"/>
                 <a:cs typeface="Calibri" pitchFamily="34" charset="-120"/>
               </a:rPr>
-              <a:t>6 archivos</a:t>
+              <a:t>7 archivos</a:t>
             </a:r>
             <a:endParaRPr lang="en-US" sz="1150" dirty="0"/>
           </a:p>
@@ -8421,7 +8753,7 @@
                 <a:ea typeface="Calibri" pitchFamily="34" charset="-122"/>
                 <a:cs typeface="Calibri" pitchFamily="34" charset="-120"/>
               </a:rPr>
-              <a:t>390 pruebas contra SQLite en memoria, sin levantar HTTP. Unos 2 minutos.</a:t>
+              <a:t>446 pruebas contra SQLite en memoria, sin levantar HTTP. Unos 2 minutos.</a:t>
             </a:r>
             <a:endParaRPr lang="en-US" sz="1100" dirty="0"/>
           </a:p>
@@ -8499,7 +8831,7 @@
                 <a:ea typeface="Calibri" pitchFamily="34" charset="-122"/>
                 <a:cs typeface="Calibri" pitchFamily="34" charset="-120"/>
               </a:rPr>
-              <a:t>La regla de la cuota la usan el módulo fiscal y la auditoría.</a:t>
+              <a:t>La regla de la cuota la usan la pantalla fiscal, la auditoría y el PDF.</a:t>
             </a:r>
             <a:endParaRPr lang="en-US" sz="1100" dirty="0"/>
           </a:p>
@@ -8831,7 +9163,7 @@
                 <a:ea typeface="Calibri" pitchFamily="34" charset="-122"/>
                 <a:cs typeface="Calibri" pitchFamily="34" charset="-120"/>
               </a:rPr>
-              <a:t>Bloque 5 · 26:00</a:t>
+              <a:t>Bloque 5 · 25:00</a:t>
             </a:r>
             <a:endParaRPr lang="en-US" sz="1050" dirty="0"/>
           </a:p>
@@ -12503,7 +12835,7 @@
                 <a:ea typeface="Calibri" pitchFamily="34" charset="-122"/>
                 <a:cs typeface="Calibri" pitchFamily="34" charset="-120"/>
               </a:rPr>
-              <a:t>8.063 líneas de backend  ·  5.344 de frontend  ·  390 pruebas  ·  9 tablas  ·  13 pantallas</a:t>
+              <a:t>8.364 líneas de backend  ·  5.454 de frontend  ·  446 pruebas  ·  9 tablas  ·  13 pantallas</a:t>
             </a:r>
             <a:endParaRPr lang="en-US" sz="1300" dirty="0"/>
           </a:p>
@@ -12691,7 +13023,7 @@
                 <a:ea typeface="Calibri" pitchFamily="34" charset="-122"/>
                 <a:cs typeface="Calibri" pitchFamily="34" charset="-120"/>
               </a:rPr>
-              <a:t>Bloque 5 · 26:30</a:t>
+              <a:t>Bloque 5 · 25:30</a:t>
             </a:r>
             <a:endParaRPr lang="en-US" sz="1050" dirty="0"/>
           </a:p>
@@ -12730,7 +13062,7 @@
                 <a:ea typeface="Georgia" pitchFamily="34" charset="-122"/>
                 <a:cs typeface="Georgia" pitchFamily="34" charset="-120"/>
               </a:rPr>
-              <a:t>32 decisiones anotadas en el código</a:t>
+              <a:t>36 decisiones anotadas en el código</a:t>
             </a:r>
             <a:endParaRPr lang="en-US" sz="3200" dirty="0"/>
           </a:p>
@@ -12835,7 +13167,7 @@
                 <a:ea typeface="Calibri" pitchFamily="34" charset="-122"/>
                 <a:cs typeface="Calibri" pitchFamily="34" charset="-120"/>
               </a:rPr>
-              <a:t>→  32 resultados en 16 archivos</a:t>
+              <a:t>→  36 resultados en 20 archivos</a:t>
             </a:r>
             <a:endParaRPr lang="en-US" sz="1400" dirty="0"/>
           </a:p>
@@ -14742,7 +15074,7 @@
                 <a:ea typeface="Calibri" pitchFamily="34" charset="-122"/>
                 <a:cs typeface="Calibri" pitchFamily="34" charset="-120"/>
               </a:rPr>
-              <a:t>Bloque 5 · 27:00</a:t>
+              <a:t>Bloque 5 · 25:45</a:t>
             </a:r>
             <a:endParaRPr lang="en-US" sz="1050" dirty="0"/>
           </a:p>
@@ -14781,7 +15113,7 @@
                 <a:ea typeface="Georgia" pitchFamily="34" charset="-122"/>
                 <a:cs typeface="Georgia" pitchFamily="34" charset="-120"/>
               </a:rPr>
-              <a:t>Dos algoritmos, dos escenarios</a:t>
+              <a:t>Dos algoritmos, una misma interfaz</a:t>
             </a:r>
             <a:endParaRPr lang="en-US" sz="3200" dirty="0"/>
           </a:p>
@@ -14847,7 +15179,7 @@
                 <a:ea typeface="Consolas" pitchFamily="34" charset="-122"/>
                 <a:cs typeface="Consolas" pitchFamily="34" charset="-120"/>
               </a:rPr>
-              <a:t>app/services/ml_service.py:726</a:t>
+              <a:t>app/services/ml_service.py:727</a:t>
             </a:r>
             <a:endParaRPr lang="en-US" sz="1050" dirty="0"/>
           </a:p>
@@ -14988,7 +15320,7 @@
                 <a:ea typeface="Calibri" pitchFamily="34" charset="-122"/>
                 <a:cs typeface="Calibri" pitchFamily="34" charset="-120"/>
               </a:rPr>
-              <a:t>El clasificador tiene que funcionar el primer día, sin datos propios, y también con cientos de gastos acumulados. Son dos escenarios estadísticos distintos y ningún algoritmo gana en los dos.</a:t>
+              <a:t>La tesis define la estrategia: Naive Bayes para conjuntos chicos y SVM lineal desde 100 ejemplos. El resto del código pide un modelo y lo usa: no sabe cuál de los dos le tocó.</a:t>
             </a:r>
             <a:endParaRPr lang="en-US" sz="1350" dirty="0"/>
           </a:p>
@@ -15015,7 +15347,7 @@
           </a:solidFill>
           <a:ln w="12700">
             <a:solidFill>
-              <a:srgbClr val="D14D4D"/>
+              <a:srgbClr val="1C7293"/>
             </a:solidFill>
             <a:prstDash val="solid"/>
           </a:ln>
@@ -15048,13 +15380,13 @@
             <a:r>
               <a:rPr lang="en-US" sz="1150" b="1" dirty="0">
                 <a:solidFill>
-                  <a:srgbClr val="D14D4D"/>
+                  <a:srgbClr val="1C7293"/>
                 </a:solidFill>
                 <a:latin typeface="Calibri" pitchFamily="34" charset="0"/>
                 <a:ea typeface="Calibri" pitchFamily="34" charset="-122"/>
                 <a:cs typeface="Calibri" pitchFamily="34" charset="-120"/>
               </a:rPr>
-              <a:t>Alternativa descartada</a:t>
+              <a:t>Lo que mostró la medición</a:t>
             </a:r>
             <a:endParaRPr lang="en-US" sz="1150" dirty="0"/>
           </a:p>
@@ -15093,7 +15425,7 @@
                 <a:ea typeface="Calibri" pitchFamily="34" charset="-122"/>
                 <a:cs typeface="Calibri" pitchFamily="34" charset="-120"/>
               </a:rPr>
-              <a:t>Fijar un solo algoritmo. Medí los dos: con el dataset base gana Naive Bayes, con datos de usuario gana el SVM. Elegir uno era aceptar el peor caso en la mitad de los escenarios.</a:t>
+              <a:t>Con 600 ejemplos: SVM 76 % · Naive Bayes 74 %. Con 96, en 50 sorteos: SVM 46 % · NB 44 %. Como el modelo siempre incluye los 600 de base, en la práctica corre SVM.</a:t>
             </a:r>
             <a:endParaRPr lang="en-US" sz="1150" dirty="0"/>
           </a:p>
@@ -15193,7 +15525,7 @@
                 <a:ea typeface="Consolas" pitchFamily="34" charset="-122"/>
                 <a:cs typeface="Consolas" pitchFamily="34" charset="-120"/>
               </a:rPr>
-              <a:t>&lt; 100 ejemplos propios</a:t>
+              <a:t>&lt; 100 ejemplos</a:t>
             </a:r>
             <a:endParaRPr lang="en-US" sz="1150" dirty="0"/>
           </a:p>
@@ -15232,7 +15564,7 @@
                 <a:ea typeface="Calibri" pitchFamily="34" charset="-122"/>
                 <a:cs typeface="Calibri" pitchFamily="34" charset="-120"/>
               </a:rPr>
-              <a:t>Asume independencia entre términos: con pocos datos no sobreajusta.</a:t>
+              <a:t>Asume independencia entre términos: la literatura lo recomienda con pocos datos.</a:t>
             </a:r>
             <a:endParaRPr lang="en-US" sz="1250" dirty="0"/>
           </a:p>
@@ -15332,7 +15664,7 @@
                 <a:ea typeface="Consolas" pitchFamily="34" charset="-122"/>
                 <a:cs typeface="Consolas" pitchFamily="34" charset="-120"/>
               </a:rPr>
-              <a:t>≥ 100 ejemplos propios</a:t>
+              <a:t>≥ 100 ejemplos</a:t>
             </a:r>
             <a:endParaRPr lang="en-US" sz="1150" dirty="0"/>
           </a:p>
@@ -15371,7 +15703,7 @@
                 <a:ea typeface="Calibri" pitchFamily="34" charset="-122"/>
                 <a:cs typeface="Calibri" pitchFamily="34" charset="-120"/>
               </a:rPr>
-              <a:t>Hiperplano de máximo margen: necesita volumen, pero después supera claramente a Naive Bayes.</a:t>
+              <a:t>Hiperplano de máximo margen. En este conjunto ganó en los dos tamaños medidos.</a:t>
             </a:r>
             <a:endParaRPr lang="en-US" sz="1250" dirty="0"/>
           </a:p>
@@ -15615,7 +15947,7 @@
                 <a:ea typeface="Calibri" pitchFamily="34" charset="-122"/>
                 <a:cs typeface="Calibri" pitchFamily="34" charset="-120"/>
               </a:rPr>
-              <a:t>Bloque 5 · 28:15</a:t>
+              <a:t>Bloque 5 · 26:15</a:t>
             </a:r>
             <a:endParaRPr lang="en-US" sz="1050" dirty="0"/>
           </a:p>
@@ -16706,7 +17038,7 @@
                 <a:ea typeface="Calibri" pitchFamily="34" charset="-122"/>
                 <a:cs typeface="Calibri" pitchFamily="34" charset="-120"/>
               </a:rPr>
-              <a:t>Bloque 5 · 29:00</a:t>
+              <a:t>Bloque 5 · 26:40</a:t>
             </a:r>
             <a:endParaRPr lang="en-US" sz="1050" dirty="0"/>
           </a:p>
@@ -18766,7 +19098,7 @@
                 <a:ea typeface="Calibri" pitchFamily="34" charset="-122"/>
                 <a:cs typeface="Calibri" pitchFamily="34" charset="-120"/>
               </a:rPr>
-              <a:t>Bloque 5 · 30:00</a:t>
+              <a:t>Bloque 5 · 27:00</a:t>
             </a:r>
             <a:endParaRPr lang="en-US" sz="1050" dirty="0"/>
           </a:p>
@@ -18805,7 +19137,7 @@
                 <a:ea typeface="Georgia" pitchFamily="34" charset="-122"/>
                 <a:cs typeface="Georgia" pitchFamily="34" charset="-120"/>
               </a:rPr>
-              <a:t>Control de acceso</a:t>
+              <a:t>Contraseñas, sesión y acceso</a:t>
             </a:r>
             <a:endParaRPr lang="en-US" sz="3200" dirty="0"/>
           </a:p>
@@ -18819,12 +19151,12 @@
         </p:nvSpPr>
         <p:spPr>
           <a:xfrm>
-            <a:off x="640080" y="1920240"/>
-            <a:ext cx="3474720" cy="2926080"/>
+            <a:off x="640080" y="1874520"/>
+            <a:ext cx="3474720" cy="2377440"/>
           </a:xfrm>
           <a:prstGeom prst="roundRect">
             <a:avLst>
-              <a:gd name="adj" fmla="val 3125"/>
+              <a:gd name="adj" fmla="val 3846"/>
             </a:avLst>
           </a:prstGeom>
           <a:solidFill>
@@ -18846,24 +19178,24 @@
         </p:nvSpPr>
         <p:spPr>
           <a:xfrm>
-            <a:off x="914400" y="2121408"/>
-            <a:ext cx="2926080" cy="457200"/>
-          </a:xfrm>
-          <a:prstGeom prst="rect">
-            <a:avLst/>
-          </a:prstGeom>
-          <a:noFill/>
-          <a:ln/>
-        </p:spPr>
-        <p:txBody>
-          <a:bodyPr wrap="square" rtlCol="0" anchor="ctr"/>
-          <a:lstStyle/>
-          <a:p>
-            <a:pPr indent="0" marL="0">
-              <a:buNone/>
-            </a:pPr>
-            <a:r>
-              <a:rPr lang="en-US" sz="1700" b="1" dirty="0">
+            <a:off x="914400" y="2011680"/>
+            <a:ext cx="2926080" cy="411480"/>
+          </a:xfrm>
+          <a:prstGeom prst="rect">
+            <a:avLst/>
+          </a:prstGeom>
+          <a:noFill/>
+          <a:ln/>
+        </p:spPr>
+        <p:txBody>
+          <a:bodyPr wrap="square" rtlCol="0" anchor="ctr"/>
+          <a:lstStyle/>
+          <a:p>
+            <a:pPr indent="0" marL="0">
+              <a:buNone/>
+            </a:pPr>
+            <a:r>
+              <a:rPr lang="en-US" sz="1650" b="1" dirty="0">
                 <a:solidFill>
                   <a:srgbClr val="02C39A"/>
                 </a:solidFill>
@@ -18871,9 +19203,9 @@
                 <a:ea typeface="Georgia" pitchFamily="34" charset="-122"/>
                 <a:cs typeface="Georgia" pitchFamily="34" charset="-120"/>
               </a:rPr>
-              <a:t>bcrypt</a:t>
-            </a:r>
-            <a:endParaRPr lang="en-US" sz="1700" dirty="0"/>
+              <a:t>Contraseña: bcrypt</a:t>
+            </a:r>
+            <a:endParaRPr lang="en-US" sz="1650" dirty="0"/>
           </a:p>
         </p:txBody>
       </p:sp>
@@ -18885,24 +19217,24 @@
         </p:nvSpPr>
         <p:spPr>
           <a:xfrm>
-            <a:off x="914400" y="2633472"/>
-            <a:ext cx="2926080" cy="1371600"/>
-          </a:xfrm>
-          <a:prstGeom prst="rect">
-            <a:avLst/>
-          </a:prstGeom>
-          <a:noFill/>
-          <a:ln/>
-        </p:spPr>
-        <p:txBody>
-          <a:bodyPr wrap="square" rtlCol="0" anchor="ctr"/>
-          <a:lstStyle/>
-          <a:p>
-            <a:pPr indent="0" marL="0">
-              <a:buNone/>
-            </a:pPr>
-            <a:r>
-              <a:rPr lang="en-US" sz="1250" dirty="0">
+            <a:off x="914400" y="2450592"/>
+            <a:ext cx="2926080" cy="960120"/>
+          </a:xfrm>
+          <a:prstGeom prst="rect">
+            <a:avLst/>
+          </a:prstGeom>
+          <a:noFill/>
+          <a:ln/>
+        </p:spPr>
+        <p:txBody>
+          <a:bodyPr wrap="square" rtlCol="0" anchor="ctr"/>
+          <a:lstStyle/>
+          <a:p>
+            <a:pPr indent="0" marL="0">
+              <a:buNone/>
+            </a:pPr>
+            <a:r>
+              <a:rPr lang="en-US" sz="1200" dirty="0">
                 <a:solidFill>
                   <a:srgbClr val="CADCFC"/>
                 </a:solidFill>
@@ -18910,9 +19242,9 @@
                 <a:ea typeface="Calibri" pitchFamily="34" charset="-122"/>
                 <a:cs typeface="Calibri" pitchFamily="34" charset="-120"/>
               </a:rPr>
-              <a:t>Las contraseñas nunca se guardan en texto plano. Función de derivación de clave adaptable en costo, con valor único por usuario.</a:t>
-            </a:r>
-            <a:endParaRPr lang="en-US" sz="1250" dirty="0"/>
+              <a:t>No se cifra: se hashea, con sal propia y costo 12. No hay forma de volver a la original.</a:t>
+            </a:r>
+            <a:endParaRPr lang="en-US" sz="1200" dirty="0"/>
           </a:p>
         </p:txBody>
       </p:sp>
@@ -18924,24 +19256,24 @@
         </p:nvSpPr>
         <p:spPr>
           <a:xfrm>
-            <a:off x="914400" y="4069080"/>
-            <a:ext cx="2926080" cy="685800"/>
-          </a:xfrm>
-          <a:prstGeom prst="rect">
-            <a:avLst/>
-          </a:prstGeom>
-          <a:noFill/>
-          <a:ln/>
-        </p:spPr>
-        <p:txBody>
-          <a:bodyPr wrap="square" rtlCol="0" anchor="ctr"/>
-          <a:lstStyle/>
-          <a:p>
-            <a:pPr indent="0" marL="0">
-              <a:buNone/>
-            </a:pPr>
-            <a:r>
-              <a:rPr lang="en-US" sz="1100" i="1" dirty="0">
+            <a:off x="914400" y="3429000"/>
+            <a:ext cx="2926080" cy="731520"/>
+          </a:xfrm>
+          <a:prstGeom prst="rect">
+            <a:avLst/>
+          </a:prstGeom>
+          <a:noFill/>
+          <a:ln/>
+        </p:spPr>
+        <p:txBody>
+          <a:bodyPr wrap="square" rtlCol="0" anchor="ctr"/>
+          <a:lstStyle/>
+          <a:p>
+            <a:pPr indent="0" marL="0">
+              <a:buNone/>
+            </a:pPr>
+            <a:r>
+              <a:rPr lang="en-US" sz="1050" i="1" dirty="0">
                 <a:solidFill>
                   <a:srgbClr val="8FA3B5"/>
                 </a:solidFill>
@@ -18949,9 +19281,9 @@
                 <a:ea typeface="Calibri" pitchFamily="34" charset="-122"/>
                 <a:cs typeface="Calibri" pitchFamily="34" charset="-120"/>
               </a:rPr>
-              <a:t>Ni ante una filtración completa de la base se recuperarían las originales.</a:t>
-            </a:r>
-            <a:endParaRPr lang="en-US" sz="1100" dirty="0"/>
+              <a:t>El login tarda lo mismo exista o no el correo: no delata quién está registrado.</a:t>
+            </a:r>
+            <a:endParaRPr lang="en-US" sz="1050" dirty="0"/>
           </a:p>
         </p:txBody>
       </p:sp>
@@ -18963,12 +19295,12 @@
         </p:nvSpPr>
         <p:spPr>
           <a:xfrm>
-            <a:off x="4343400" y="1920240"/>
-            <a:ext cx="3474720" cy="2926080"/>
+            <a:off x="4343400" y="1874520"/>
+            <a:ext cx="3474720" cy="2377440"/>
           </a:xfrm>
           <a:prstGeom prst="roundRect">
             <a:avLst>
-              <a:gd name="adj" fmla="val 3125"/>
+              <a:gd name="adj" fmla="val 3846"/>
             </a:avLst>
           </a:prstGeom>
           <a:solidFill>
@@ -18990,24 +19322,24 @@
         </p:nvSpPr>
         <p:spPr>
           <a:xfrm>
-            <a:off x="4617720" y="2121408"/>
-            <a:ext cx="2926080" cy="457200"/>
-          </a:xfrm>
-          <a:prstGeom prst="rect">
-            <a:avLst/>
-          </a:prstGeom>
-          <a:noFill/>
-          <a:ln/>
-        </p:spPr>
-        <p:txBody>
-          <a:bodyPr wrap="square" rtlCol="0" anchor="ctr"/>
-          <a:lstStyle/>
-          <a:p>
-            <a:pPr indent="0" marL="0">
-              <a:buNone/>
-            </a:pPr>
-            <a:r>
-              <a:rPr lang="en-US" sz="1700" b="1" dirty="0">
+            <a:off x="4617720" y="2011680"/>
+            <a:ext cx="2926080" cy="411480"/>
+          </a:xfrm>
+          <a:prstGeom prst="rect">
+            <a:avLst/>
+          </a:prstGeom>
+          <a:noFill/>
+          <a:ln/>
+        </p:spPr>
+        <p:txBody>
+          <a:bodyPr wrap="square" rtlCol="0" anchor="ctr"/>
+          <a:lstStyle/>
+          <a:p>
+            <a:pPr indent="0" marL="0">
+              <a:buNone/>
+            </a:pPr>
+            <a:r>
+              <a:rPr lang="en-US" sz="1650" b="1" dirty="0">
                 <a:solidFill>
                   <a:srgbClr val="02C39A"/>
                 </a:solidFill>
@@ -19015,9 +19347,9 @@
                 <a:ea typeface="Georgia" pitchFamily="34" charset="-122"/>
                 <a:cs typeface="Georgia" pitchFamily="34" charset="-120"/>
               </a:rPr>
-              <a:t>JWT · HMAC-SHA256</a:t>
-            </a:r>
-            <a:endParaRPr lang="en-US" sz="1700" dirty="0"/>
+              <a:t>Sesión: token firmado</a:t>
+            </a:r>
+            <a:endParaRPr lang="en-US" sz="1650" dirty="0"/>
           </a:p>
         </p:txBody>
       </p:sp>
@@ -19029,24 +19361,24 @@
         </p:nvSpPr>
         <p:spPr>
           <a:xfrm>
-            <a:off x="4617720" y="2633472"/>
-            <a:ext cx="2926080" cy="1371600"/>
-          </a:xfrm>
-          <a:prstGeom prst="rect">
-            <a:avLst/>
-          </a:prstGeom>
-          <a:noFill/>
-          <a:ln/>
-        </p:spPr>
-        <p:txBody>
-          <a:bodyPr wrap="square" rtlCol="0" anchor="ctr"/>
-          <a:lstStyle/>
-          <a:p>
-            <a:pPr indent="0" marL="0">
-              <a:buNone/>
-            </a:pPr>
-            <a:r>
-              <a:rPr lang="en-US" sz="1250" dirty="0">
+            <a:off x="4617720" y="2450592"/>
+            <a:ext cx="2926080" cy="960120"/>
+          </a:xfrm>
+          <a:prstGeom prst="rect">
+            <a:avLst/>
+          </a:prstGeom>
+          <a:noFill/>
+          <a:ln/>
+        </p:spPr>
+        <p:txBody>
+          <a:bodyPr wrap="square" rtlCol="0" anchor="ctr"/>
+          <a:lstStyle/>
+          <a:p>
+            <a:pPr indent="0" marL="0">
+              <a:buNone/>
+            </a:pPr>
+            <a:r>
+              <a:rPr lang="en-US" sz="1200" dirty="0">
                 <a:solidFill>
                   <a:srgbClr val="CADCFC"/>
                 </a:solidFill>
@@ -19054,9 +19386,9 @@
                 <a:ea typeface="Calibri" pitchFamily="34" charset="-122"/>
                 <a:cs typeface="Calibri" pitchFamily="34" charset="-120"/>
               </a:rPr>
-              <a:t>Token firmado con vigencia de siete días. La clave de firma vive en una variable de entorno, fuera del código fuente.</a:t>
-            </a:r>
-            <a:endParaRPr lang="en-US" sz="1250" dirty="0"/>
+              <a:t>HMAC-SHA256, vence a los 7 días. Firmado no es cifrado: se puede leer, pero no modificar.</a:t>
+            </a:r>
+            <a:endParaRPr lang="en-US" sz="1200" dirty="0"/>
           </a:p>
         </p:txBody>
       </p:sp>
@@ -19068,24 +19400,24 @@
         </p:nvSpPr>
         <p:spPr>
           <a:xfrm>
-            <a:off x="4617720" y="4069080"/>
-            <a:ext cx="2926080" cy="685800"/>
-          </a:xfrm>
-          <a:prstGeom prst="rect">
-            <a:avLst/>
-          </a:prstGeom>
-          <a:noFill/>
-          <a:ln/>
-        </p:spPr>
-        <p:txBody>
-          <a:bodyPr wrap="square" rtlCol="0" anchor="ctr"/>
-          <a:lstStyle/>
-          <a:p>
-            <a:pPr indent="0" marL="0">
-              <a:buNone/>
-            </a:pPr>
-            <a:r>
-              <a:rPr lang="en-US" sz="1100" i="1" dirty="0">
+            <a:off x="4617720" y="3429000"/>
+            <a:ext cx="2926080" cy="731520"/>
+          </a:xfrm>
+          <a:prstGeom prst="rect">
+            <a:avLst/>
+          </a:prstGeom>
+          <a:noFill/>
+          <a:ln/>
+        </p:spPr>
+        <p:txBody>
+          <a:bodyPr wrap="square" rtlCol="0" anchor="ctr"/>
+          <a:lstStyle/>
+          <a:p>
+            <a:pPr indent="0" marL="0">
+              <a:buNone/>
+            </a:pPr>
+            <a:r>
+              <a:rPr lang="en-US" sz="1050" i="1" dirty="0">
                 <a:solidFill>
                   <a:srgbClr val="8FA3B5"/>
                 </a:solidFill>
@@ -19093,9 +19425,9 @@
                 <a:ea typeface="Calibri" pitchFamily="34" charset="-122"/>
                 <a:cs typeface="Calibri" pitchFamily="34" charset="-120"/>
               </a:rPr>
-              <a:t>Cada petición viaja con el token en el encabezado de autorización.</a:t>
-            </a:r>
-            <a:endParaRPr lang="en-US" sz="1100" dirty="0"/>
+              <a:t>La clave de firma vive en el .env; sin ella, o si es débil, la API no arranca.</a:t>
+            </a:r>
+            <a:endParaRPr lang="en-US" sz="1050" dirty="0"/>
           </a:p>
         </p:txBody>
       </p:sp>
@@ -19107,12 +19439,12 @@
         </p:nvSpPr>
         <p:spPr>
           <a:xfrm>
-            <a:off x="8046720" y="1920240"/>
-            <a:ext cx="3474720" cy="2926080"/>
+            <a:off x="8046720" y="1874520"/>
+            <a:ext cx="3474720" cy="2377440"/>
           </a:xfrm>
           <a:prstGeom prst="roundRect">
             <a:avLst>
-              <a:gd name="adj" fmla="val 3125"/>
+              <a:gd name="adj" fmla="val 3846"/>
             </a:avLst>
           </a:prstGeom>
           <a:solidFill>
@@ -19134,24 +19466,24 @@
         </p:nvSpPr>
         <p:spPr>
           <a:xfrm>
-            <a:off x="8321040" y="2121408"/>
-            <a:ext cx="2926080" cy="457200"/>
-          </a:xfrm>
-          <a:prstGeom prst="rect">
-            <a:avLst/>
-          </a:prstGeom>
-          <a:noFill/>
-          <a:ln/>
-        </p:spPr>
-        <p:txBody>
-          <a:bodyPr wrap="square" rtlCol="0" anchor="ctr"/>
-          <a:lstStyle/>
-          <a:p>
-            <a:pPr indent="0" marL="0">
-              <a:buNone/>
-            </a:pPr>
-            <a:r>
-              <a:rPr lang="en-US" sz="1700" b="1" dirty="0">
+            <a:off x="8321040" y="2011680"/>
+            <a:ext cx="2926080" cy="411480"/>
+          </a:xfrm>
+          <a:prstGeom prst="rect">
+            <a:avLst/>
+          </a:prstGeom>
+          <a:noFill/>
+          <a:ln/>
+        </p:spPr>
+        <p:txBody>
+          <a:bodyPr wrap="square" rtlCol="0" anchor="ctr"/>
+          <a:lstStyle/>
+          <a:p>
+            <a:pPr indent="0" marL="0">
+              <a:buNone/>
+            </a:pPr>
+            <a:r>
+              <a:rPr lang="en-US" sz="1650" b="1" dirty="0">
                 <a:solidFill>
                   <a:srgbClr val="02C39A"/>
                 </a:solidFill>
@@ -19159,9 +19491,9 @@
                 <a:ea typeface="Georgia" pitchFamily="34" charset="-122"/>
                 <a:cs typeface="Georgia" pitchFamily="34" charset="-120"/>
               </a:rPr>
-              <a:t>Aislamiento por usuario</a:t>
-            </a:r>
-            <a:endParaRPr lang="en-US" sz="1700" dirty="0"/>
+              <a:t>Quién ve qué</a:t>
+            </a:r>
+            <a:endParaRPr lang="en-US" sz="1650" dirty="0"/>
           </a:p>
         </p:txBody>
       </p:sp>
@@ -19173,24 +19505,24 @@
         </p:nvSpPr>
         <p:spPr>
           <a:xfrm>
-            <a:off x="8321040" y="2633472"/>
-            <a:ext cx="2926080" cy="1371600"/>
-          </a:xfrm>
-          <a:prstGeom prst="rect">
-            <a:avLst/>
-          </a:prstGeom>
-          <a:noFill/>
-          <a:ln/>
-        </p:spPr>
-        <p:txBody>
-          <a:bodyPr wrap="square" rtlCol="0" anchor="ctr"/>
-          <a:lstStyle/>
-          <a:p>
-            <a:pPr indent="0" marL="0">
-              <a:buNone/>
-            </a:pPr>
-            <a:r>
-              <a:rPr lang="en-US" sz="1250" dirty="0">
+            <a:off x="8321040" y="2450592"/>
+            <a:ext cx="2926080" cy="960120"/>
+          </a:xfrm>
+          <a:prstGeom prst="rect">
+            <a:avLst/>
+          </a:prstGeom>
+          <a:noFill/>
+          <a:ln/>
+        </p:spPr>
+        <p:txBody>
+          <a:bodyPr wrap="square" rtlCol="0" anchor="ctr"/>
+          <a:lstStyle/>
+          <a:p>
+            <a:pPr indent="0" marL="0">
+              <a:buNone/>
+            </a:pPr>
+            <a:r>
+              <a:rPr lang="en-US" sz="1200" dirty="0">
                 <a:solidFill>
                   <a:srgbClr val="CADCFC"/>
                 </a:solidFill>
@@ -19198,9 +19530,9 @@
                 <a:ea typeface="Calibri" pitchFamily="34" charset="-122"/>
                 <a:cs typeface="Calibri" pitchFamily="34" charset="-120"/>
               </a:rPr>
-              <a:t>Todas las consultas se filtran por el identificador obtenido del token.</a:t>
-            </a:r>
-            <a:endParaRPr lang="en-US" sz="1250" dirty="0"/>
+              <a:t>El usuario sale siempre del token. Lo ajeno responde 404, igual que lo inexistente.</a:t>
+            </a:r>
+            <a:endParaRPr lang="en-US" sz="1200" dirty="0"/>
           </a:p>
         </p:txBody>
       </p:sp>
@@ -19212,24 +19544,24 @@
         </p:nvSpPr>
         <p:spPr>
           <a:xfrm>
-            <a:off x="8321040" y="4069080"/>
-            <a:ext cx="2926080" cy="685800"/>
-          </a:xfrm>
-          <a:prstGeom prst="rect">
-            <a:avLst/>
-          </a:prstGeom>
-          <a:noFill/>
-          <a:ln/>
-        </p:spPr>
-        <p:txBody>
-          <a:bodyPr wrap="square" rtlCol="0" anchor="ctr"/>
-          <a:lstStyle/>
-          <a:p>
-            <a:pPr indent="0" marL="0">
-              <a:buNone/>
-            </a:pPr>
-            <a:r>
-              <a:rPr lang="en-US" sz="1100" i="1" dirty="0">
+            <a:off x="8321040" y="3429000"/>
+            <a:ext cx="2926080" cy="731520"/>
+          </a:xfrm>
+          <a:prstGeom prst="rect">
+            <a:avLst/>
+          </a:prstGeom>
+          <a:noFill/>
+          <a:ln/>
+        </p:spPr>
+        <p:txBody>
+          <a:bodyPr wrap="square" rtlCol="0" anchor="ctr"/>
+          <a:lstStyle/>
+          <a:p>
+            <a:pPr indent="0" marL="0">
+              <a:buNone/>
+            </a:pPr>
+            <a:r>
+              <a:rPr lang="en-US" sz="1050" i="1" dirty="0">
                 <a:solidFill>
                   <a:srgbClr val="8FA3B5"/>
                 </a:solidFill>
@@ -19237,9 +19569,9 @@
                 <a:ea typeface="Calibri" pitchFamily="34" charset="-122"/>
                 <a:cs typeface="Calibri" pitchFamily="34" charset="-120"/>
               </a:rPr>
-              <a:t>La separación entre cuentas se garantiza en cada operación, no en la interfaz.</a:t>
-            </a:r>
-            <a:endParaRPr lang="en-US" sz="1100" dirty="0"/>
+              <a:t>Base, API y app atienden solo en esta computadora (127.0.0.1).</a:t>
+            </a:r>
+            <a:endParaRPr lang="en-US" sz="1050" dirty="0"/>
           </a:p>
         </p:txBody>
       </p:sp>
@@ -19251,12 +19583,117 @@
         </p:nvSpPr>
         <p:spPr>
           <a:xfrm>
-            <a:off x="640080" y="5120640"/>
-            <a:ext cx="10881360" cy="1143000"/>
+            <a:off x="640080" y="4434840"/>
+            <a:ext cx="10881360" cy="749808"/>
           </a:xfrm>
           <a:prstGeom prst="roundRect">
             <a:avLst>
-              <a:gd name="adj" fmla="val 8000"/>
+              <a:gd name="adj" fmla="val 9756"/>
+            </a:avLst>
+          </a:prstGeom>
+          <a:solidFill>
+            <a:srgbClr val="14395E"/>
+          </a:solidFill>
+          <a:ln w="12700">
+            <a:solidFill>
+              <a:srgbClr val="D14D4D"/>
+            </a:solidFill>
+            <a:prstDash val="solid"/>
+          </a:ln>
+        </p:spPr>
+      </p:sp>
+      <p:sp>
+        <p:nvSpPr>
+          <p:cNvPr id="18" name="Text 16"/>
+          <p:cNvSpPr/>
+          <p:nvPr/>
+        </p:nvSpPr>
+        <p:spPr>
+          <a:xfrm>
+            <a:off x="914400" y="4480560"/>
+            <a:ext cx="5486400" cy="274320"/>
+          </a:xfrm>
+          <a:prstGeom prst="rect">
+            <a:avLst/>
+          </a:prstGeom>
+          <a:noFill/>
+          <a:ln/>
+        </p:spPr>
+        <p:txBody>
+          <a:bodyPr wrap="square" rtlCol="0" anchor="ctr"/>
+          <a:lstStyle/>
+          <a:p>
+            <a:pPr indent="0" marL="0">
+              <a:buNone/>
+            </a:pPr>
+            <a:r>
+              <a:rPr lang="en-US" sz="1050" b="1" spc="150" kern="0" dirty="0">
+                <a:solidFill>
+                  <a:srgbClr val="D14D4D"/>
+                </a:solidFill>
+                <a:latin typeface="Calibri" pitchFamily="34" charset="0"/>
+                <a:ea typeface="Calibri" pitchFamily="34" charset="-122"/>
+                <a:cs typeface="Calibri" pitchFamily="34" charset="-120"/>
+              </a:rPr>
+              <a:t>LO QUE NO HACE (para producción)</a:t>
+            </a:r>
+            <a:endParaRPr lang="en-US" sz="1050" dirty="0"/>
+          </a:p>
+        </p:txBody>
+      </p:sp>
+      <p:sp>
+        <p:nvSpPr>
+          <p:cNvPr id="19" name="Text 17"/>
+          <p:cNvSpPr/>
+          <p:nvPr/>
+        </p:nvSpPr>
+        <p:spPr>
+          <a:xfrm>
+            <a:off x="914400" y="4754880"/>
+            <a:ext cx="10332720" cy="365760"/>
+          </a:xfrm>
+          <a:prstGeom prst="rect">
+            <a:avLst/>
+          </a:prstGeom>
+          <a:noFill/>
+          <a:ln/>
+        </p:spPr>
+        <p:txBody>
+          <a:bodyPr wrap="square" rtlCol="0" anchor="ctr"/>
+          <a:lstStyle/>
+          <a:p>
+            <a:pPr indent="0" marL="0">
+              <a:buNone/>
+            </a:pPr>
+            <a:r>
+              <a:rPr lang="en-US" sz="1200" dirty="0">
+                <a:solidFill>
+                  <a:srgbClr val="CADCFC"/>
+                </a:solidFill>
+                <a:latin typeface="Calibri" pitchFamily="34" charset="0"/>
+                <a:ea typeface="Calibri" pitchFamily="34" charset="-122"/>
+                <a:cs typeface="Calibri" pitchFamily="34" charset="-120"/>
+              </a:rPr>
+              <a:t>La base no está cifrada en disco  ·  un token no se puede anular antes de que venza  ·  no hay límite de intentos de inicio de sesión</a:t>
+            </a:r>
+            <a:endParaRPr lang="en-US" sz="1200" dirty="0"/>
+          </a:p>
+        </p:txBody>
+      </p:sp>
+      <p:sp>
+        <p:nvSpPr>
+          <p:cNvPr id="20" name="Shape 18"/>
+          <p:cNvSpPr/>
+          <p:nvPr/>
+        </p:nvSpPr>
+        <p:spPr>
+          <a:xfrm>
+            <a:off x="640080" y="5349240"/>
+            <a:ext cx="10881360" cy="960120"/>
+          </a:xfrm>
+          <a:prstGeom prst="roundRect">
+            <a:avLst>
+              <a:gd name="adj" fmla="val 9524"/>
             </a:avLst>
           </a:prstGeom>
           <a:solidFill>
@@ -19267,30 +19704,30 @@
       </p:sp>
       <p:sp>
         <p:nvSpPr>
-          <p:cNvPr id="18" name="Text 16"/>
-          <p:cNvSpPr/>
-          <p:nvPr/>
-        </p:nvSpPr>
-        <p:spPr>
-          <a:xfrm>
-            <a:off x="914400" y="5212080"/>
-            <a:ext cx="10332720" cy="502920"/>
-          </a:xfrm>
-          <a:prstGeom prst="rect">
-            <a:avLst/>
-          </a:prstGeom>
-          <a:noFill/>
-          <a:ln/>
-        </p:spPr>
-        <p:txBody>
-          <a:bodyPr wrap="square" rtlCol="0" anchor="ctr"/>
-          <a:lstStyle/>
-          <a:p>
-            <a:pPr indent="0" marL="0">
-              <a:buNone/>
-            </a:pPr>
-            <a:r>
-              <a:rPr lang="en-US" sz="1900" b="1" dirty="0">
+          <p:cNvPr id="21" name="Text 19"/>
+          <p:cNvSpPr/>
+          <p:nvPr/>
+        </p:nvSpPr>
+        <p:spPr>
+          <a:xfrm>
+            <a:off x="914400" y="5413248"/>
+            <a:ext cx="10332720" cy="411480"/>
+          </a:xfrm>
+          <a:prstGeom prst="rect">
+            <a:avLst/>
+          </a:prstGeom>
+          <a:noFill/>
+          <a:ln/>
+        </p:spPr>
+        <p:txBody>
+          <a:bodyPr wrap="square" rtlCol="0" anchor="ctr"/>
+          <a:lstStyle/>
+          <a:p>
+            <a:pPr indent="0" marL="0">
+              <a:buNone/>
+            </a:pPr>
+            <a:r>
+              <a:rPr lang="en-US" sz="1650" b="1" dirty="0">
                 <a:solidFill>
                   <a:srgbClr val="0D2B45"/>
                 </a:solidFill>
@@ -19300,36 +19737,36 @@
               </a:rPr>
               <a:t>El identificador del usuario se obtiene siempre del token, nunca del cuerpo de la petición.</a:t>
             </a:r>
-            <a:endParaRPr lang="en-US" sz="1900" dirty="0"/>
-          </a:p>
-        </p:txBody>
-      </p:sp>
-      <p:sp>
-        <p:nvSpPr>
-          <p:cNvPr id="19" name="Text 17"/>
-          <p:cNvSpPr/>
-          <p:nvPr/>
-        </p:nvSpPr>
-        <p:spPr>
-          <a:xfrm>
-            <a:off x="914400" y="5715000"/>
-            <a:ext cx="10332720" cy="411480"/>
-          </a:xfrm>
-          <a:prstGeom prst="rect">
-            <a:avLst/>
-          </a:prstGeom>
-          <a:noFill/>
-          <a:ln/>
-        </p:spPr>
-        <p:txBody>
-          <a:bodyPr wrap="square" rtlCol="0" anchor="ctr"/>
-          <a:lstStyle/>
-          <a:p>
-            <a:pPr indent="0" marL="0">
-              <a:buNone/>
-            </a:pPr>
-            <a:r>
-              <a:rPr lang="en-US" sz="1300" dirty="0">
+            <a:endParaRPr lang="en-US" sz="1650" dirty="0"/>
+          </a:p>
+        </p:txBody>
+      </p:sp>
+      <p:sp>
+        <p:nvSpPr>
+          <p:cNvPr id="22" name="Text 20"/>
+          <p:cNvSpPr/>
+          <p:nvPr/>
+        </p:nvSpPr>
+        <p:spPr>
+          <a:xfrm>
+            <a:off x="914400" y="5852160"/>
+            <a:ext cx="10332720" cy="365760"/>
+          </a:xfrm>
+          <a:prstGeom prst="rect">
+            <a:avLst/>
+          </a:prstGeom>
+          <a:noFill/>
+          <a:ln/>
+        </p:spPr>
+        <p:txBody>
+          <a:bodyPr wrap="square" rtlCol="0" anchor="ctr"/>
+          <a:lstStyle/>
+          <a:p>
+            <a:pPr indent="0" marL="0">
+              <a:buNone/>
+            </a:pPr>
+            <a:r>
+              <a:rPr lang="en-US" sz="1250" dirty="0">
                 <a:solidFill>
                   <a:srgbClr val="14395E"/>
                 </a:solidFill>
@@ -19339,13 +19776,13 @@
               </a:rPr>
               <a:t>Principio transversal del diseño: un cliente no puede manipular a quién pertenecen los datos.</a:t>
             </a:r>
-            <a:endParaRPr lang="en-US" sz="1300" dirty="0"/>
-          </a:p>
-        </p:txBody>
-      </p:sp>
-      <p:sp>
-        <p:nvSpPr>
-          <p:cNvPr id="20" name="Text 18"/>
+            <a:endParaRPr lang="en-US" sz="1250" dirty="0"/>
+          </a:p>
+        </p:txBody>
+      </p:sp>
+      <p:sp>
+        <p:nvSpPr>
+          <p:cNvPr id="23" name="Text 21"/>
           <p:cNvSpPr/>
           <p:nvPr/>
         </p:nvSpPr>
@@ -19384,7 +19821,7 @@
       </p:sp>
       <p:sp>
         <p:nvSpPr>
-          <p:cNvPr id="21" name="Text 19"/>
+          <p:cNvPr id="24" name="Text 22"/>
           <p:cNvSpPr/>
           <p:nvPr/>
         </p:nvSpPr>
@@ -19525,7 +19962,7 @@
                 <a:ea typeface="Calibri" pitchFamily="34" charset="-122"/>
                 <a:cs typeface="Calibri" pitchFamily="34" charset="-120"/>
               </a:rPr>
-              <a:t>Bloque 5 · 31:00</a:t>
+              <a:t>Bloque 5 · 29:00</a:t>
             </a:r>
             <a:endParaRPr lang="en-US" sz="1050" dirty="0"/>
           </a:p>
@@ -20532,7 +20969,7 @@
                 <a:ea typeface="Calibri" pitchFamily="34" charset="-122"/>
                 <a:cs typeface="Calibri" pitchFamily="34" charset="-120"/>
               </a:rPr>
-              <a:t>Bloque 5 · 32:00</a:t>
+              <a:t>Bloque 5 · 30:00</a:t>
             </a:r>
             <a:endParaRPr lang="en-US" sz="1050" dirty="0"/>
           </a:p>
@@ -20925,7 +21362,7 @@
                 <a:ea typeface="Consolas" pitchFamily="34" charset="-122"/>
                 <a:cs typeface="Consolas" pitchFamily="34" charset="-120"/>
               </a:rPr>
-              <a:t>app/services/ml_service.py:830  ·  _confianza_svm()</a:t>
+              <a:t>app/services/ml_service.py:831  ·  _confianza_svm()</a:t>
             </a:r>
             <a:endParaRPr lang="en-US" sz="1050" dirty="0"/>
           </a:p>
@@ -21214,7 +21651,7 @@
                 <a:ea typeface="Calibri" pitchFamily="34" charset="-122"/>
                 <a:cs typeface="Calibri" pitchFamily="34" charset="-120"/>
               </a:rPr>
-              <a:t>Bloque 5 · 32:45</a:t>
+              <a:t>Bloque 5 · 32:30</a:t>
             </a:r>
             <a:endParaRPr lang="en-US" sz="1050" dirty="0"/>
           </a:p>
@@ -24069,7 +24506,7 @@
                 <a:ea typeface="Georgia" pitchFamily="34" charset="-122"/>
                 <a:cs typeface="Georgia" pitchFamily="34" charset="-120"/>
               </a:rPr>
-              <a:t>390</a:t>
+              <a:t>446</a:t>
             </a:r>
             <a:endParaRPr lang="en-US" sz="2600" dirty="0"/>
           </a:p>
@@ -25310,7 +25747,7 @@
                 <a:ea typeface="Georgia" pitchFamily="34" charset="-122"/>
                 <a:cs typeface="Georgia" pitchFamily="34" charset="-120"/>
               </a:rPr>
-              <a:t>Cuota de Monotributo sin registrar</a:t>
+              <a:t>Cuota de Monotributo sin cubrir</a:t>
             </a:r>
             <a:endParaRPr lang="en-US" sz="1450" dirty="0"/>
           </a:p>
@@ -25349,7 +25786,7 @@
                 <a:ea typeface="Calibri" pitchFamily="34" charset="-122"/>
                 <a:cs typeface="Calibri" pitchFamily="34" charset="-120"/>
               </a:rPr>
-              <a:t>Ausencia del pago de la cuota en el mes corriente, con tolerancia del 1 %.</a:t>
+              <a:t>Lo registrado en el mes, en uno o varios pagos, no cubre la cuota de la categoría (tolerancia del 1 %).</a:t>
             </a:r>
             <a:endParaRPr lang="en-US" sz="1150" dirty="0"/>
           </a:p>
@@ -27312,7 +27749,7 @@
                 <a:ea typeface="Consolas" pitchFamily="34" charset="-122"/>
                 <a:cs typeface="Consolas" pitchFamily="34" charset="-120"/>
               </a:rPr>
-              <a:t>database.py:38</a:t>
+              <a:t>database.py:40</a:t>
             </a:r>
             <a:endParaRPr lang="en-US" sz="1050" dirty="0"/>
           </a:p>
@@ -27612,7 +28049,7 @@
                 <a:ea typeface="Consolas" pitchFamily="34" charset="-122"/>
                 <a:cs typeface="Consolas" pitchFamily="34" charset="-120"/>
               </a:rPr>
-              <a:t>ml_service.py:726</a:t>
+              <a:t>ml_service.py:727</a:t>
             </a:r>
             <a:endParaRPr lang="en-US" sz="1050" dirty="0"/>
           </a:p>
@@ -27712,7 +28149,7 @@
                 <a:ea typeface="Consolas" pitchFamily="34" charset="-122"/>
                 <a:cs typeface="Consolas" pitchFamily="34" charset="-120"/>
               </a:rPr>
-              <a:t>ml_service.py:711</a:t>
+              <a:t>ml_service.py:712</a:t>
             </a:r>
             <a:endParaRPr lang="en-US" sz="1050" dirty="0"/>
           </a:p>
@@ -27812,7 +28249,7 @@
                 <a:ea typeface="Consolas" pitchFamily="34" charset="-122"/>
                 <a:cs typeface="Consolas" pitchFamily="34" charset="-120"/>
               </a:rPr>
-              <a:t>ml_service.py:830</a:t>
+              <a:t>ml_service.py:831</a:t>
             </a:r>
             <a:endParaRPr lang="en-US" sz="1050" dirty="0"/>
           </a:p>
@@ -27912,7 +28349,7 @@
                 <a:ea typeface="Consolas" pitchFamily="34" charset="-122"/>
                 <a:cs typeface="Consolas" pitchFamily="34" charset="-120"/>
               </a:rPr>
-              <a:t>prophet_service.py:179</a:t>
+              <a:t>prophet_service.py:203</a:t>
             </a:r>
             <a:endParaRPr lang="en-US" sz="1050" dirty="0"/>
           </a:p>
@@ -28012,7 +28449,7 @@
                 <a:ea typeface="Consolas" pitchFamily="34" charset="-122"/>
                 <a:cs typeface="Consolas" pitchFamily="34" charset="-120"/>
               </a:rPr>
-              <a:t>csv_service.py:41</a:t>
+              <a:t>csv_service.py:42</a:t>
             </a:r>
             <a:endParaRPr lang="en-US" sz="1050" dirty="0"/>
           </a:p>
@@ -28112,7 +28549,7 @@
                 <a:ea typeface="Consolas" pitchFamily="34" charset="-122"/>
                 <a:cs typeface="Consolas" pitchFamily="34" charset="-120"/>
               </a:rPr>
-              <a:t>csv_service.py:738</a:t>
+              <a:t>csv_service.py:786</a:t>
             </a:r>
             <a:endParaRPr lang="en-US" sz="1050" dirty="0"/>
           </a:p>
@@ -28512,7 +28949,7 @@
                 <a:ea typeface="Consolas" pitchFamily="34" charset="-122"/>
                 <a:cs typeface="Consolas" pitchFamily="34" charset="-120"/>
               </a:rPr>
-              <a:t>reportes_service.py:535</a:t>
+              <a:t>reportes_service.py:517</a:t>
             </a:r>
             <a:endParaRPr lang="en-US" sz="1050" dirty="0"/>
           </a:p>
@@ -28612,7 +29049,7 @@
                 <a:ea typeface="Consolas" pitchFamily="34" charset="-122"/>
                 <a:cs typeface="Consolas" pitchFamily="34" charset="-120"/>
               </a:rPr>
-              <a:t>monotributo_service.py:66</a:t>
+              <a:t>monotributo_service.py:67</a:t>
             </a:r>
             <a:endParaRPr lang="en-US" sz="1050" dirty="0"/>
           </a:p>
@@ -28712,7 +29149,7 @@
                 <a:ea typeface="Consolas" pitchFamily="34" charset="-122"/>
                 <a:cs typeface="Consolas" pitchFamily="34" charset="-120"/>
               </a:rPr>
-              <a:t>api.js:23</a:t>
+              <a:t>api.js:24</a:t>
             </a:r>
             <a:endParaRPr lang="en-US" sz="1050" dirty="0"/>
           </a:p>
@@ -32536,12 +32973,12 @@
         </p:nvSpPr>
         <p:spPr>
           <a:xfrm>
-            <a:off x="640080" y="2011680"/>
-            <a:ext cx="5257800" cy="1005840"/>
+            <a:off x="640080" y="1874520"/>
+            <a:ext cx="5257800" cy="786384"/>
           </a:xfrm>
           <a:prstGeom prst="roundRect">
             <a:avLst>
-              <a:gd name="adj" fmla="val 7273"/>
+              <a:gd name="adj" fmla="val 9302"/>
             </a:avLst>
           </a:prstGeom>
           <a:solidFill>
@@ -32570,8 +33007,8 @@
         </p:nvSpPr>
         <p:spPr>
           <a:xfrm>
-            <a:off x="640080" y="2011680"/>
-            <a:ext cx="137160" cy="1005840"/>
+            <a:off x="640080" y="1874520"/>
+            <a:ext cx="137160" cy="786384"/>
           </a:xfrm>
           <a:prstGeom prst="roundRect">
             <a:avLst>
@@ -32592,24 +33029,24 @@
         </p:nvSpPr>
         <p:spPr>
           <a:xfrm>
-            <a:off x="1005840" y="2121408"/>
-            <a:ext cx="4663440" cy="384048"/>
-          </a:xfrm>
-          <a:prstGeom prst="rect">
-            <a:avLst/>
-          </a:prstGeom>
-          <a:noFill/>
-          <a:ln/>
-        </p:spPr>
-        <p:txBody>
-          <a:bodyPr wrap="square" rtlCol="0" anchor="ctr"/>
-          <a:lstStyle/>
-          <a:p>
-            <a:pPr indent="0" marL="0">
-              <a:buNone/>
-            </a:pPr>
-            <a:r>
-              <a:rPr lang="en-US" sz="1550" b="1" dirty="0">
+            <a:off x="1005840" y="1938528"/>
+            <a:ext cx="4663440" cy="347472"/>
+          </a:xfrm>
+          <a:prstGeom prst="rect">
+            <a:avLst/>
+          </a:prstGeom>
+          <a:noFill/>
+          <a:ln/>
+        </p:spPr>
+        <p:txBody>
+          <a:bodyPr wrap="square" rtlCol="0" anchor="ctr"/>
+          <a:lstStyle/>
+          <a:p>
+            <a:pPr indent="0" marL="0">
+              <a:buNone/>
+            </a:pPr>
+            <a:r>
+              <a:rPr lang="en-US" sz="1450" b="1" dirty="0">
                 <a:solidFill>
                   <a:srgbClr val="16222E"/>
                 </a:solidFill>
@@ -32617,9 +33054,9 @@
                 <a:ea typeface="Georgia" pitchFamily="34" charset="-122"/>
                 <a:cs typeface="Georgia" pitchFamily="34" charset="-120"/>
               </a:rPr>
-              <a:t>Monotributo</a:t>
-            </a:r>
-            <a:endParaRPr lang="en-US" sz="1550" dirty="0"/>
+              <a:t>Dashboard</a:t>
+            </a:r>
+            <a:endParaRPr lang="en-US" sz="1450" dirty="0"/>
           </a:p>
         </p:txBody>
       </p:sp>
@@ -32631,24 +33068,24 @@
         </p:nvSpPr>
         <p:spPr>
           <a:xfrm>
-            <a:off x="1005840" y="2514600"/>
-            <a:ext cx="4663440" cy="411480"/>
-          </a:xfrm>
-          <a:prstGeom prst="rect">
-            <a:avLst/>
-          </a:prstGeom>
-          <a:noFill/>
-          <a:ln/>
-        </p:spPr>
-        <p:txBody>
-          <a:bodyPr wrap="square" rtlCol="0" anchor="ctr"/>
-          <a:lstStyle/>
-          <a:p>
-            <a:pPr indent="0" marL="0">
-              <a:buNone/>
-            </a:pPr>
-            <a:r>
-              <a:rPr lang="en-US" sz="1200" dirty="0">
+            <a:off x="1005840" y="2276856"/>
+            <a:ext cx="4663440" cy="329184"/>
+          </a:xfrm>
+          <a:prstGeom prst="rect">
+            <a:avLst/>
+          </a:prstGeom>
+          <a:noFill/>
+          <a:ln/>
+        </p:spPr>
+        <p:txBody>
+          <a:bodyPr wrap="square" rtlCol="0" anchor="ctr"/>
+          <a:lstStyle/>
+          <a:p>
+            <a:pPr indent="0" marL="0">
+              <a:buNone/>
+            </a:pPr>
+            <a:r>
+              <a:rPr lang="en-US" sz="1150" dirty="0">
                 <a:solidFill>
                   <a:srgbClr val="4A5A68"/>
                 </a:solidFill>
@@ -32656,9 +33093,9 @@
                 <a:ea typeface="Calibri" pitchFamily="34" charset="-122"/>
                 <a:cs typeface="Calibri" pitchFamily="34" charset="-120"/>
               </a:rPr>
-              <a:t>La categorización definitiva la determina ARCA</a:t>
-            </a:r>
-            <a:endParaRPr lang="en-US" sz="1200" dirty="0"/>
+              <a:t>La proyección es una estimación y la recomendación, orientativa</a:t>
+            </a:r>
+            <a:endParaRPr lang="en-US" sz="1150" dirty="0"/>
           </a:p>
         </p:txBody>
       </p:sp>
@@ -32670,12 +33107,12 @@
         </p:nvSpPr>
         <p:spPr>
           <a:xfrm>
-            <a:off x="6217920" y="2011680"/>
-            <a:ext cx="5257800" cy="1005840"/>
+            <a:off x="6217920" y="1874520"/>
+            <a:ext cx="5257800" cy="786384"/>
           </a:xfrm>
           <a:prstGeom prst="roundRect">
             <a:avLst>
-              <a:gd name="adj" fmla="val 7273"/>
+              <a:gd name="adj" fmla="val 9302"/>
             </a:avLst>
           </a:prstGeom>
           <a:solidFill>
@@ -32704,8 +33141,8 @@
         </p:nvSpPr>
         <p:spPr>
           <a:xfrm>
-            <a:off x="6217920" y="2011680"/>
-            <a:ext cx="137160" cy="1005840"/>
+            <a:off x="6217920" y="1874520"/>
+            <a:ext cx="137160" cy="786384"/>
           </a:xfrm>
           <a:prstGeom prst="roundRect">
             <a:avLst>
@@ -32726,24 +33163,24 @@
         </p:nvSpPr>
         <p:spPr>
           <a:xfrm>
-            <a:off x="6583680" y="2121408"/>
-            <a:ext cx="4663440" cy="384048"/>
-          </a:xfrm>
-          <a:prstGeom prst="rect">
-            <a:avLst/>
-          </a:prstGeom>
-          <a:noFill/>
-          <a:ln/>
-        </p:spPr>
-        <p:txBody>
-          <a:bodyPr wrap="square" rtlCol="0" anchor="ctr"/>
-          <a:lstStyle/>
-          <a:p>
-            <a:pPr indent="0" marL="0">
-              <a:buNone/>
-            </a:pPr>
-            <a:r>
-              <a:rPr lang="en-US" sz="1550" b="1" dirty="0">
+            <a:off x="6583680" y="1938528"/>
+            <a:ext cx="4663440" cy="347472"/>
+          </a:xfrm>
+          <a:prstGeom prst="rect">
+            <a:avLst/>
+          </a:prstGeom>
+          <a:noFill/>
+          <a:ln/>
+        </p:spPr>
+        <p:txBody>
+          <a:bodyPr wrap="square" rtlCol="0" anchor="ctr"/>
+          <a:lstStyle/>
+          <a:p>
+            <a:pPr indent="0" marL="0">
+              <a:buNone/>
+            </a:pPr>
+            <a:r>
+              <a:rPr lang="en-US" sz="1450" b="1" dirty="0">
                 <a:solidFill>
                   <a:srgbClr val="16222E"/>
                 </a:solidFill>
@@ -32751,9 +33188,9 @@
                 <a:ea typeface="Georgia" pitchFamily="34" charset="-122"/>
                 <a:cs typeface="Georgia" pitchFamily="34" charset="-120"/>
               </a:rPr>
-              <a:t>Proyecciones</a:t>
-            </a:r>
-            <a:endParaRPr lang="en-US" sz="1550" dirty="0"/>
+              <a:t>Monotributo</a:t>
+            </a:r>
+            <a:endParaRPr lang="en-US" sz="1450" dirty="0"/>
           </a:p>
         </p:txBody>
       </p:sp>
@@ -32765,24 +33202,24 @@
         </p:nvSpPr>
         <p:spPr>
           <a:xfrm>
-            <a:off x="6583680" y="2514600"/>
-            <a:ext cx="4663440" cy="411480"/>
-          </a:xfrm>
-          <a:prstGeom prst="rect">
-            <a:avLst/>
-          </a:prstGeom>
-          <a:noFill/>
-          <a:ln/>
-        </p:spPr>
-        <p:txBody>
-          <a:bodyPr wrap="square" rtlCol="0" anchor="ctr"/>
-          <a:lstStyle/>
-          <a:p>
-            <a:pPr indent="0" marL="0">
-              <a:buNone/>
-            </a:pPr>
-            <a:r>
-              <a:rPr lang="en-US" sz="1200" dirty="0">
+            <a:off x="6583680" y="2276856"/>
+            <a:ext cx="4663440" cy="329184"/>
+          </a:xfrm>
+          <a:prstGeom prst="rect">
+            <a:avLst/>
+          </a:prstGeom>
+          <a:noFill/>
+          <a:ln/>
+        </p:spPr>
+        <p:txBody>
+          <a:bodyPr wrap="square" rtlCol="0" anchor="ctr"/>
+          <a:lstStyle/>
+          <a:p>
+            <a:pPr indent="0" marL="0">
+              <a:buNone/>
+            </a:pPr>
+            <a:r>
+              <a:rPr lang="en-US" sz="1150" dirty="0">
                 <a:solidFill>
                   <a:srgbClr val="4A5A68"/>
                 </a:solidFill>
@@ -32790,9 +33227,9 @@
                 <a:ea typeface="Calibri" pitchFamily="34" charset="-122"/>
                 <a:cs typeface="Calibri" pitchFamily="34" charset="-120"/>
               </a:rPr>
-              <a:t>Son estimaciones estadísticas, no una garantía de ingresos</a:t>
-            </a:r>
-            <a:endParaRPr lang="en-US" sz="1200" dirty="0"/>
+              <a:t>La categorización definitiva la determina ARCA</a:t>
+            </a:r>
+            <a:endParaRPr lang="en-US" sz="1150" dirty="0"/>
           </a:p>
         </p:txBody>
       </p:sp>
@@ -32804,12 +33241,12 @@
         </p:nvSpPr>
         <p:spPr>
           <a:xfrm>
-            <a:off x="640080" y="3246120"/>
-            <a:ext cx="5257800" cy="1005840"/>
+            <a:off x="640080" y="2788920"/>
+            <a:ext cx="5257800" cy="786384"/>
           </a:xfrm>
           <a:prstGeom prst="roundRect">
             <a:avLst>
-              <a:gd name="adj" fmla="val 7273"/>
+              <a:gd name="adj" fmla="val 9302"/>
             </a:avLst>
           </a:prstGeom>
           <a:solidFill>
@@ -32838,8 +33275,8 @@
         </p:nvSpPr>
         <p:spPr>
           <a:xfrm>
-            <a:off x="640080" y="3246120"/>
-            <a:ext cx="137160" cy="1005840"/>
+            <a:off x="640080" y="2788920"/>
+            <a:ext cx="137160" cy="786384"/>
           </a:xfrm>
           <a:prstGeom prst="roundRect">
             <a:avLst>
@@ -32860,24 +33297,24 @@
         </p:nvSpPr>
         <p:spPr>
           <a:xfrm>
-            <a:off x="1005840" y="3355848"/>
-            <a:ext cx="4663440" cy="384048"/>
-          </a:xfrm>
-          <a:prstGeom prst="rect">
-            <a:avLst/>
-          </a:prstGeom>
-          <a:noFill/>
-          <a:ln/>
-        </p:spPr>
-        <p:txBody>
-          <a:bodyPr wrap="square" rtlCol="0" anchor="ctr"/>
-          <a:lstStyle/>
-          <a:p>
-            <a:pPr indent="0" marL="0">
-              <a:buNone/>
-            </a:pPr>
-            <a:r>
-              <a:rPr lang="en-US" sz="1550" b="1" dirty="0">
+            <a:off x="1005840" y="2852928"/>
+            <a:ext cx="4663440" cy="347472"/>
+          </a:xfrm>
+          <a:prstGeom prst="rect">
+            <a:avLst/>
+          </a:prstGeom>
+          <a:noFill/>
+          <a:ln/>
+        </p:spPr>
+        <p:txBody>
+          <a:bodyPr wrap="square" rtlCol="0" anchor="ctr"/>
+          <a:lstStyle/>
+          <a:p>
+            <a:pPr indent="0" marL="0">
+              <a:buNone/>
+            </a:pPr>
+            <a:r>
+              <a:rPr lang="en-US" sz="1450" b="1" dirty="0">
                 <a:solidFill>
                   <a:srgbClr val="16222E"/>
                 </a:solidFill>
@@ -32885,9 +33322,9 @@
                 <a:ea typeface="Georgia" pitchFamily="34" charset="-122"/>
                 <a:cs typeface="Georgia" pitchFamily="34" charset="-120"/>
               </a:rPr>
-              <a:t>Recomendaciones</a:t>
-            </a:r>
-            <a:endParaRPr lang="en-US" sz="1550" dirty="0"/>
+              <a:t>Proyecciones</a:t>
+            </a:r>
+            <a:endParaRPr lang="en-US" sz="1450" dirty="0"/>
           </a:p>
         </p:txBody>
       </p:sp>
@@ -32899,24 +33336,24 @@
         </p:nvSpPr>
         <p:spPr>
           <a:xfrm>
-            <a:off x="1005840" y="3749040"/>
-            <a:ext cx="4663440" cy="411480"/>
-          </a:xfrm>
-          <a:prstGeom prst="rect">
-            <a:avLst/>
-          </a:prstGeom>
-          <a:noFill/>
-          <a:ln/>
-        </p:spPr>
-        <p:txBody>
-          <a:bodyPr wrap="square" rtlCol="0" anchor="ctr"/>
-          <a:lstStyle/>
-          <a:p>
-            <a:pPr indent="0" marL="0">
-              <a:buNone/>
-            </a:pPr>
-            <a:r>
-              <a:rPr lang="en-US" sz="1200" dirty="0">
+            <a:off x="1005840" y="3191256"/>
+            <a:ext cx="4663440" cy="329184"/>
+          </a:xfrm>
+          <a:prstGeom prst="rect">
+            <a:avLst/>
+          </a:prstGeom>
+          <a:noFill/>
+          <a:ln/>
+        </p:spPr>
+        <p:txBody>
+          <a:bodyPr wrap="square" rtlCol="0" anchor="ctr"/>
+          <a:lstStyle/>
+          <a:p>
+            <a:pPr indent="0" marL="0">
+              <a:buNone/>
+            </a:pPr>
+            <a:r>
+              <a:rPr lang="en-US" sz="1150" dirty="0">
                 <a:solidFill>
                   <a:srgbClr val="4A5A68"/>
                 </a:solidFill>
@@ -32924,9 +33361,9 @@
                 <a:ea typeface="Calibri" pitchFamily="34" charset="-122"/>
                 <a:cs typeface="Calibri" pitchFamily="34" charset="-120"/>
               </a:rPr>
-              <a:t>Reglas sobre sus propios datos, de carácter orientativo</a:t>
-            </a:r>
-            <a:endParaRPr lang="en-US" sz="1200" dirty="0"/>
+              <a:t>Son estimaciones estadísticas, no una garantía de ingresos</a:t>
+            </a:r>
+            <a:endParaRPr lang="en-US" sz="1150" dirty="0"/>
           </a:p>
         </p:txBody>
       </p:sp>
@@ -32938,12 +33375,12 @@
         </p:nvSpPr>
         <p:spPr>
           <a:xfrm>
-            <a:off x="6217920" y="3246120"/>
-            <a:ext cx="5257800" cy="1005840"/>
+            <a:off x="6217920" y="2788920"/>
+            <a:ext cx="5257800" cy="786384"/>
           </a:xfrm>
           <a:prstGeom prst="roundRect">
             <a:avLst>
-              <a:gd name="adj" fmla="val 7273"/>
+              <a:gd name="adj" fmla="val 9302"/>
             </a:avLst>
           </a:prstGeom>
           <a:solidFill>
@@ -32972,8 +33409,8 @@
         </p:nvSpPr>
         <p:spPr>
           <a:xfrm>
-            <a:off x="6217920" y="3246120"/>
-            <a:ext cx="137160" cy="1005840"/>
+            <a:off x="6217920" y="2788920"/>
+            <a:ext cx="137160" cy="786384"/>
           </a:xfrm>
           <a:prstGeom prst="roundRect">
             <a:avLst>
@@ -32994,24 +33431,24 @@
         </p:nvSpPr>
         <p:spPr>
           <a:xfrm>
-            <a:off x="6583680" y="3355848"/>
-            <a:ext cx="4663440" cy="384048"/>
-          </a:xfrm>
-          <a:prstGeom prst="rect">
-            <a:avLst/>
-          </a:prstGeom>
-          <a:noFill/>
-          <a:ln/>
-        </p:spPr>
-        <p:txBody>
-          <a:bodyPr wrap="square" rtlCol="0" anchor="ctr"/>
-          <a:lstStyle/>
-          <a:p>
-            <a:pPr indent="0" marL="0">
-              <a:buNone/>
-            </a:pPr>
-            <a:r>
-              <a:rPr lang="en-US" sz="1550" b="1" dirty="0">
+            <a:off x="6583680" y="2852928"/>
+            <a:ext cx="4663440" cy="347472"/>
+          </a:xfrm>
+          <a:prstGeom prst="rect">
+            <a:avLst/>
+          </a:prstGeom>
+          <a:noFill/>
+          <a:ln/>
+        </p:spPr>
+        <p:txBody>
+          <a:bodyPr wrap="square" rtlCol="0" anchor="ctr"/>
+          <a:lstStyle/>
+          <a:p>
+            <a:pPr indent="0" marL="0">
+              <a:buNone/>
+            </a:pPr>
+            <a:r>
+              <a:rPr lang="en-US" sz="1450" b="1" dirty="0">
                 <a:solidFill>
                   <a:srgbClr val="16222E"/>
                 </a:solidFill>
@@ -33019,9 +33456,9 @@
                 <a:ea typeface="Georgia" pitchFamily="34" charset="-122"/>
                 <a:cs typeface="Georgia" pitchFamily="34" charset="-120"/>
               </a:rPr>
-              <a:t>Resumen IA</a:t>
-            </a:r>
-            <a:endParaRPr lang="en-US" sz="1550" dirty="0"/>
+              <a:t>Recomendaciones</a:t>
+            </a:r>
+            <a:endParaRPr lang="en-US" sz="1450" dirty="0"/>
           </a:p>
         </p:txBody>
       </p:sp>
@@ -33033,24 +33470,24 @@
         </p:nvSpPr>
         <p:spPr>
           <a:xfrm>
-            <a:off x="6583680" y="3749040"/>
-            <a:ext cx="4663440" cy="411480"/>
-          </a:xfrm>
-          <a:prstGeom prst="rect">
-            <a:avLst/>
-          </a:prstGeom>
-          <a:noFill/>
-          <a:ln/>
-        </p:spPr>
-        <p:txBody>
-          <a:bodyPr wrap="square" rtlCol="0" anchor="ctr"/>
-          <a:lstStyle/>
-          <a:p>
-            <a:pPr indent="0" marL="0">
-              <a:buNone/>
-            </a:pPr>
-            <a:r>
-              <a:rPr lang="en-US" sz="1200" dirty="0">
+            <a:off x="6583680" y="3191256"/>
+            <a:ext cx="4663440" cy="329184"/>
+          </a:xfrm>
+          <a:prstGeom prst="rect">
+            <a:avLst/>
+          </a:prstGeom>
+          <a:noFill/>
+          <a:ln/>
+        </p:spPr>
+        <p:txBody>
+          <a:bodyPr wrap="square" rtlCol="0" anchor="ctr"/>
+          <a:lstStyle/>
+          <a:p>
+            <a:pPr indent="0" marL="0">
+              <a:buNone/>
+            </a:pPr>
+            <a:r>
+              <a:rPr lang="en-US" sz="1150" dirty="0">
                 <a:solidFill>
                   <a:srgbClr val="4A5A68"/>
                 </a:solidFill>
@@ -33058,9 +33495,9 @@
                 <a:ea typeface="Calibri" pitchFamily="34" charset="-122"/>
                 <a:cs typeface="Calibri" pitchFamily="34" charset="-120"/>
               </a:rPr>
-              <a:t>Redactado por un modelo de lenguaje: verificar las cifras</a:t>
-            </a:r>
-            <a:endParaRPr lang="en-US" sz="1200" dirty="0"/>
+              <a:t>Reglas sobre sus propios datos, de carácter orientativo</a:t>
+            </a:r>
+            <a:endParaRPr lang="en-US" sz="1150" dirty="0"/>
           </a:p>
         </p:txBody>
       </p:sp>
@@ -33072,12 +33509,12 @@
         </p:nvSpPr>
         <p:spPr>
           <a:xfrm>
-            <a:off x="640080" y="4480560"/>
-            <a:ext cx="5257800" cy="1005840"/>
+            <a:off x="640080" y="3703320"/>
+            <a:ext cx="5257800" cy="786384"/>
           </a:xfrm>
           <a:prstGeom prst="roundRect">
             <a:avLst>
-              <a:gd name="adj" fmla="val 7273"/>
+              <a:gd name="adj" fmla="val 9302"/>
             </a:avLst>
           </a:prstGeom>
           <a:solidFill>
@@ -33106,8 +33543,8 @@
         </p:nvSpPr>
         <p:spPr>
           <a:xfrm>
-            <a:off x="640080" y="4480560"/>
-            <a:ext cx="137160" cy="1005840"/>
+            <a:off x="640080" y="3703320"/>
+            <a:ext cx="137160" cy="786384"/>
           </a:xfrm>
           <a:prstGeom prst="roundRect">
             <a:avLst>
@@ -33128,24 +33565,24 @@
         </p:nvSpPr>
         <p:spPr>
           <a:xfrm>
-            <a:off x="1005840" y="4590288"/>
-            <a:ext cx="4663440" cy="384048"/>
-          </a:xfrm>
-          <a:prstGeom prst="rect">
-            <a:avLst/>
-          </a:prstGeom>
-          <a:noFill/>
-          <a:ln/>
-        </p:spPr>
-        <p:txBody>
-          <a:bodyPr wrap="square" rtlCol="0" anchor="ctr"/>
-          <a:lstStyle/>
-          <a:p>
-            <a:pPr indent="0" marL="0">
-              <a:buNone/>
-            </a:pPr>
-            <a:r>
-              <a:rPr lang="en-US" sz="1550" b="1" dirty="0">
+            <a:off x="1005840" y="3767328"/>
+            <a:ext cx="4663440" cy="347472"/>
+          </a:xfrm>
+          <a:prstGeom prst="rect">
+            <a:avLst/>
+          </a:prstGeom>
+          <a:noFill/>
+          <a:ln/>
+        </p:spPr>
+        <p:txBody>
+          <a:bodyPr wrap="square" rtlCol="0" anchor="ctr"/>
+          <a:lstStyle/>
+          <a:p>
+            <a:pPr indent="0" marL="0">
+              <a:buNone/>
+            </a:pPr>
+            <a:r>
+              <a:rPr lang="en-US" sz="1450" b="1" dirty="0">
                 <a:solidFill>
                   <a:srgbClr val="16222E"/>
                 </a:solidFill>
@@ -33153,9 +33590,9 @@
                 <a:ea typeface="Georgia" pitchFamily="34" charset="-122"/>
                 <a:cs typeface="Georgia" pitchFamily="34" charset="-120"/>
               </a:rPr>
-              <a:t>Auditoría</a:t>
-            </a:r>
-            <a:endParaRPr lang="en-US" sz="1550" dirty="0"/>
+              <a:t>Resumen IA</a:t>
+            </a:r>
+            <a:endParaRPr lang="en-US" sz="1450" dirty="0"/>
           </a:p>
         </p:txBody>
       </p:sp>
@@ -33167,24 +33604,24 @@
         </p:nvSpPr>
         <p:spPr>
           <a:xfrm>
-            <a:off x="1005840" y="4983480"/>
-            <a:ext cx="4663440" cy="411480"/>
-          </a:xfrm>
-          <a:prstGeom prst="rect">
-            <a:avLst/>
-          </a:prstGeom>
-          <a:noFill/>
-          <a:ln/>
-        </p:spPr>
-        <p:txBody>
-          <a:bodyPr wrap="square" rtlCol="0" anchor="ctr"/>
-          <a:lstStyle/>
-          <a:p>
-            <a:pPr indent="0" marL="0">
-              <a:buNone/>
-            </a:pPr>
-            <a:r>
-              <a:rPr lang="en-US" sz="1200" dirty="0">
+            <a:off x="1005840" y="4105656"/>
+            <a:ext cx="4663440" cy="329184"/>
+          </a:xfrm>
+          <a:prstGeom prst="rect">
+            <a:avLst/>
+          </a:prstGeom>
+          <a:noFill/>
+          <a:ln/>
+        </p:spPr>
+        <p:txBody>
+          <a:bodyPr wrap="square" rtlCol="0" anchor="ctr"/>
+          <a:lstStyle/>
+          <a:p>
+            <a:pPr indent="0" marL="0">
+              <a:buNone/>
+            </a:pPr>
+            <a:r>
+              <a:rPr lang="en-US" sz="1150" dirty="0">
                 <a:solidFill>
                   <a:srgbClr val="4A5A68"/>
                 </a:solidFill>
@@ -33192,9 +33629,9 @@
                 <a:ea typeface="Calibri" pitchFamily="34" charset="-122"/>
                 <a:cs typeface="Calibri" pitchFamily="34" charset="-120"/>
               </a:rPr>
-              <a:t>Señala posibles inconsistencias, no dictamina un error</a:t>
-            </a:r>
-            <a:endParaRPr lang="en-US" sz="1200" dirty="0"/>
+              <a:t>Redactado por un modelo de lenguaje: verificar las cifras</a:t>
+            </a:r>
+            <a:endParaRPr lang="en-US" sz="1150" dirty="0"/>
           </a:p>
         </p:txBody>
       </p:sp>
@@ -33206,12 +33643,12 @@
         </p:nvSpPr>
         <p:spPr>
           <a:xfrm>
-            <a:off x="6217920" y="4480560"/>
-            <a:ext cx="5257800" cy="1005840"/>
+            <a:off x="6217920" y="3703320"/>
+            <a:ext cx="5257800" cy="786384"/>
           </a:xfrm>
           <a:prstGeom prst="roundRect">
             <a:avLst>
-              <a:gd name="adj" fmla="val 7273"/>
+              <a:gd name="adj" fmla="val 9302"/>
             </a:avLst>
           </a:prstGeom>
           <a:solidFill>
@@ -33240,8 +33677,8 @@
         </p:nvSpPr>
         <p:spPr>
           <a:xfrm>
-            <a:off x="6217920" y="4480560"/>
-            <a:ext cx="137160" cy="1005840"/>
+            <a:off x="6217920" y="3703320"/>
+            <a:ext cx="137160" cy="786384"/>
           </a:xfrm>
           <a:prstGeom prst="roundRect">
             <a:avLst>
@@ -33249,7 +33686,7 @@
             </a:avLst>
           </a:prstGeom>
           <a:solidFill>
-            <a:srgbClr val="E0A82E"/>
+            <a:srgbClr val="1C7293"/>
           </a:solidFill>
           <a:ln/>
         </p:spPr>
@@ -33262,34 +33699,34 @@
         </p:nvSpPr>
         <p:spPr>
           <a:xfrm>
-            <a:off x="6583680" y="4590288"/>
-            <a:ext cx="4663440" cy="384048"/>
-          </a:xfrm>
-          <a:prstGeom prst="rect">
-            <a:avLst/>
-          </a:prstGeom>
-          <a:noFill/>
-          <a:ln/>
-        </p:spPr>
-        <p:txBody>
-          <a:bodyPr wrap="square" rtlCol="0" anchor="ctr"/>
-          <a:lstStyle/>
-          <a:p>
-            <a:pPr indent="0" marL="0">
-              <a:buNone/>
-            </a:pPr>
-            <a:r>
-              <a:rPr lang="en-US" sz="1550" b="1" dirty="0">
-                <a:solidFill>
-                  <a:srgbClr val="8A6410"/>
+            <a:off x="6583680" y="3767328"/>
+            <a:ext cx="4663440" cy="347472"/>
+          </a:xfrm>
+          <a:prstGeom prst="rect">
+            <a:avLst/>
+          </a:prstGeom>
+          <a:noFill/>
+          <a:ln/>
+        </p:spPr>
+        <p:txBody>
+          <a:bodyPr wrap="square" rtlCol="0" anchor="ctr"/>
+          <a:lstStyle/>
+          <a:p>
+            <a:pPr indent="0" marL="0">
+              <a:buNone/>
+            </a:pPr>
+            <a:r>
+              <a:rPr lang="en-US" sz="1450" b="1" dirty="0">
+                <a:solidFill>
+                  <a:srgbClr val="16222E"/>
                 </a:solidFill>
                 <a:latin typeface="Georgia" pitchFamily="34" charset="0"/>
                 <a:ea typeface="Georgia" pitchFamily="34" charset="-122"/>
                 <a:cs typeface="Georgia" pitchFamily="34" charset="-120"/>
               </a:rPr>
-              <a:t>Reporte PDF</a:t>
-            </a:r>
-            <a:endParaRPr lang="en-US" sz="1550" dirty="0"/>
+              <a:t>Auditoría</a:t>
+            </a:r>
+            <a:endParaRPr lang="en-US" sz="1450" dirty="0"/>
           </a:p>
         </p:txBody>
       </p:sp>
@@ -33301,24 +33738,24 @@
         </p:nvSpPr>
         <p:spPr>
           <a:xfrm>
-            <a:off x="6583680" y="4983480"/>
-            <a:ext cx="4663440" cy="411480"/>
-          </a:xfrm>
-          <a:prstGeom prst="rect">
-            <a:avLst/>
-          </a:prstGeom>
-          <a:noFill/>
-          <a:ln/>
-        </p:spPr>
-        <p:txBody>
-          <a:bodyPr wrap="square" rtlCol="0" anchor="ctr"/>
-          <a:lstStyle/>
-          <a:p>
-            <a:pPr indent="0" marL="0">
-              <a:buNone/>
-            </a:pPr>
-            <a:r>
-              <a:rPr lang="en-US" sz="1200" dirty="0">
+            <a:off x="6583680" y="4105656"/>
+            <a:ext cx="4663440" cy="329184"/>
+          </a:xfrm>
+          <a:prstGeom prst="rect">
+            <a:avLst/>
+          </a:prstGeom>
+          <a:noFill/>
+          <a:ln/>
+        </p:spPr>
+        <p:txBody>
+          <a:bodyPr wrap="square" rtlCol="0" anchor="ctr"/>
+          <a:lstStyle/>
+          <a:p>
+            <a:pPr indent="0" marL="0">
+              <a:buNone/>
+            </a:pPr>
+            <a:r>
+              <a:rPr lang="en-US" sz="1150" dirty="0">
                 <a:solidFill>
                   <a:srgbClr val="4A5A68"/>
                 </a:solidFill>
@@ -33326,15 +33763,149 @@
                 <a:ea typeface="Calibri" pitchFamily="34" charset="-122"/>
                 <a:cs typeface="Calibri" pitchFamily="34" charset="-120"/>
               </a:rPr>
+              <a:t>Señala posibles inconsistencias, no dictamina un error</a:t>
+            </a:r>
+            <a:endParaRPr lang="en-US" sz="1150" dirty="0"/>
+          </a:p>
+        </p:txBody>
+      </p:sp>
+      <p:sp>
+        <p:nvSpPr>
+          <p:cNvPr id="29" name="Shape 27"/>
+          <p:cNvSpPr/>
+          <p:nvPr/>
+        </p:nvSpPr>
+        <p:spPr>
+          <a:xfrm>
+            <a:off x="640080" y="4617720"/>
+            <a:ext cx="10835640" cy="786384"/>
+          </a:xfrm>
+          <a:prstGeom prst="roundRect">
+            <a:avLst>
+              <a:gd name="adj" fmla="val 9302"/>
+            </a:avLst>
+          </a:prstGeom>
+          <a:solidFill>
+            <a:srgbClr val="FFFFFF"/>
+          </a:solidFill>
+          <a:ln w="12700">
+            <a:solidFill>
+              <a:srgbClr val="DCE4EC"/>
+            </a:solidFill>
+            <a:prstDash val="solid"/>
+          </a:ln>
+          <a:effectLst>
+            <a:outerShdw sx="100000" sy="100000" kx="0" ky="0" algn="bl" rotWithShape="0" blurRad="76200" dist="25400" dir="5400000">
+              <a:srgbClr val="AAB7C4">
+                <a:alpha val="28000"/>
+              </a:srgbClr>
+            </a:outerShdw>
+          </a:effectLst>
+        </p:spPr>
+      </p:sp>
+      <p:sp>
+        <p:nvSpPr>
+          <p:cNvPr id="30" name="Shape 28"/>
+          <p:cNvSpPr/>
+          <p:nvPr/>
+        </p:nvSpPr>
+        <p:spPr>
+          <a:xfrm>
+            <a:off x="640080" y="4617720"/>
+            <a:ext cx="137160" cy="786384"/>
+          </a:xfrm>
+          <a:prstGeom prst="roundRect">
+            <a:avLst>
+              <a:gd name="adj" fmla="val 26667"/>
+            </a:avLst>
+          </a:prstGeom>
+          <a:solidFill>
+            <a:srgbClr val="E0A82E"/>
+          </a:solidFill>
+          <a:ln/>
+        </p:spPr>
+      </p:sp>
+      <p:sp>
+        <p:nvSpPr>
+          <p:cNvPr id="31" name="Text 29"/>
+          <p:cNvSpPr/>
+          <p:nvPr/>
+        </p:nvSpPr>
+        <p:spPr>
+          <a:xfrm>
+            <a:off x="1005840" y="4681728"/>
+            <a:ext cx="10241280" cy="347472"/>
+          </a:xfrm>
+          <a:prstGeom prst="rect">
+            <a:avLst/>
+          </a:prstGeom>
+          <a:noFill/>
+          <a:ln/>
+        </p:spPr>
+        <p:txBody>
+          <a:bodyPr wrap="square" rtlCol="0" anchor="ctr"/>
+          <a:lstStyle/>
+          <a:p>
+            <a:pPr indent="0" marL="0">
+              <a:buNone/>
+            </a:pPr>
+            <a:r>
+              <a:rPr lang="en-US" sz="1450" b="1" dirty="0">
+                <a:solidFill>
+                  <a:srgbClr val="8A6410"/>
+                </a:solidFill>
+                <a:latin typeface="Georgia" pitchFamily="34" charset="0"/>
+                <a:ea typeface="Georgia" pitchFamily="34" charset="-122"/>
+                <a:cs typeface="Georgia" pitchFamily="34" charset="-120"/>
+              </a:rPr>
+              <a:t>Reporte PDF</a:t>
+            </a:r>
+            <a:endParaRPr lang="en-US" sz="1450" dirty="0"/>
+          </a:p>
+        </p:txBody>
+      </p:sp>
+      <p:sp>
+        <p:nvSpPr>
+          <p:cNvPr id="32" name="Text 30"/>
+          <p:cNvSpPr/>
+          <p:nvPr/>
+        </p:nvSpPr>
+        <p:spPr>
+          <a:xfrm>
+            <a:off x="1005840" y="5020056"/>
+            <a:ext cx="10241280" cy="329184"/>
+          </a:xfrm>
+          <a:prstGeom prst="rect">
+            <a:avLst/>
+          </a:prstGeom>
+          <a:noFill/>
+          <a:ln/>
+        </p:spPr>
+        <p:txBody>
+          <a:bodyPr wrap="square" rtlCol="0" anchor="ctr"/>
+          <a:lstStyle/>
+          <a:p>
+            <a:pPr indent="0" marL="0">
+              <a:buNone/>
+            </a:pPr>
+            <a:r>
+              <a:rPr lang="en-US" sz="1150" dirty="0">
+                <a:solidFill>
+                  <a:srgbClr val="4A5A68"/>
+                </a:solidFill>
+                <a:latin typeface="Calibri" pitchFamily="34" charset="0"/>
+                <a:ea typeface="Calibri" pitchFamily="34" charset="-122"/>
+                <a:cs typeface="Calibri" pitchFamily="34" charset="-120"/>
+              </a:rPr>
               <a:t>Además: verificar contra la documentación respaldatoria</a:t>
             </a:r>
-            <a:endParaRPr lang="en-US" sz="1200" dirty="0"/>
-          </a:p>
-        </p:txBody>
-      </p:sp>
-      <p:sp>
-        <p:nvSpPr>
-          <p:cNvPr id="29" name="Shape 27"/>
+            <a:endParaRPr lang="en-US" sz="1150" dirty="0"/>
+          </a:p>
+        </p:txBody>
+      </p:sp>
+      <p:sp>
+        <p:nvSpPr>
+          <p:cNvPr id="33" name="Shape 31"/>
           <p:cNvSpPr/>
           <p:nvPr/>
         </p:nvSpPr>
@@ -33356,7 +33927,7 @@
       </p:sp>
       <p:sp>
         <p:nvSpPr>
-          <p:cNvPr id="30" name="Text 28"/>
+          <p:cNvPr id="34" name="Text 32"/>
           <p:cNvSpPr/>
           <p:nvPr/>
         </p:nvSpPr>
@@ -33395,7 +33966,7 @@
       </p:sp>
       <p:sp>
         <p:nvSpPr>
-          <p:cNvPr id="31" name="Text 29"/>
+          <p:cNvPr id="35" name="Text 33"/>
           <p:cNvSpPr/>
           <p:nvPr/>
         </p:nvSpPr>
@@ -33434,7 +34005,7 @@
       </p:sp>
       <p:sp>
         <p:nvSpPr>
-          <p:cNvPr id="32" name="Text 30"/>
+          <p:cNvPr id="36" name="Text 34"/>
           <p:cNvSpPr/>
           <p:nvPr/>
         </p:nvSpPr>

</xml_diff>